<commit_message>
updating fig4a to be consistent with fig 3
</commit_message>
<xml_diff>
--- a/figures/Evaluation_of_Real_Models_PointsvsMAE.pptx
+++ b/figures/Evaluation_of_Real_Models_PointsvsMAE.pptx
@@ -5,7 +5,7 @@
     <p:sldMasterId id="2147483648" r:id="rId1"/>
   </p:sldMasterIdLst>
   <p:sldIdLst>
-    <p:sldId id="256" r:id="rId6"/>
+    <p:sldId id="256" r:id="rId2"/>
   </p:sldIdLst>
   <p:sldSz cx="10698163" cy="7562850"/>
   <p:notesSz cx="6858000" cy="9144000"/>
@@ -104,6 +104,22 @@
       </a:defRPr>
     </a:lvl9pPr>
   </p:defaultTextStyle>
+  <p:extLst>
+    <p:ext uri="{EFAFB233-063F-42B5-8137-9DF3F51BA10A}">
+      <p15:sldGuideLst xmlns:p15="http://schemas.microsoft.com/office/powerpoint/2012/main">
+        <p15:guide id="1" orient="horz" pos="2382">
+          <p15:clr>
+            <a:srgbClr val="A4A3A4"/>
+          </p15:clr>
+        </p15:guide>
+        <p15:guide id="2" pos="3370">
+          <p15:clr>
+            <a:srgbClr val="A4A3A4"/>
+          </p15:clr>
+        </p15:guide>
+      </p15:sldGuideLst>
+    </p:ext>
+  </p:extLst>
 </p:presentation>
 </file>
 
@@ -145,7 +161,7 @@
           <a:lstStyle/>
           <a:p>
             <a:r>
-              <a:rPr lang="en-US" smtClean="0"/>
+              <a:rPr lang="en-US"/>
               <a:t>Click to edit Master title style</a:t>
             </a:r>
             <a:endParaRPr lang="en-GB"/>
@@ -264,7 +280,7 @@
           </a:lstStyle>
           <a:p>
             <a:r>
-              <a:rPr lang="en-US" smtClean="0"/>
+              <a:rPr lang="en-US"/>
               <a:t>Click to edit Master subtitle style</a:t>
             </a:r>
             <a:endParaRPr lang="en-GB"/>
@@ -288,7 +304,7 @@
           <a:p>
             <a:fld id="{6BA5D40C-A8DC-479A-A5D3-E7B4936A184B}" type="datetimeFigureOut">
               <a:rPr lang="en-GB" smtClean="0"/>
-              <a:t>15/07/2015</a:t>
+              <a:t>20/05/2026</a:t>
             </a:fld>
             <a:endParaRPr lang="en-GB"/>
           </a:p>
@@ -382,7 +398,7 @@
           <a:lstStyle/>
           <a:p>
             <a:r>
-              <a:rPr lang="en-US" smtClean="0"/>
+              <a:rPr lang="en-US"/>
               <a:t>Click to edit Master title style</a:t>
             </a:r>
             <a:endParaRPr lang="en-GB"/>
@@ -406,35 +422,35 @@
           <a:p>
             <a:pPr lvl="0"/>
             <a:r>
-              <a:rPr lang="en-US" smtClean="0"/>
+              <a:rPr lang="en-US"/>
               <a:t>Click to edit Master text styles</a:t>
             </a:r>
           </a:p>
           <a:p>
             <a:pPr lvl="1"/>
             <a:r>
-              <a:rPr lang="en-US" smtClean="0"/>
+              <a:rPr lang="en-US"/>
               <a:t>Second level</a:t>
             </a:r>
           </a:p>
           <a:p>
             <a:pPr lvl="2"/>
             <a:r>
-              <a:rPr lang="en-US" smtClean="0"/>
+              <a:rPr lang="en-US"/>
               <a:t>Third level</a:t>
             </a:r>
           </a:p>
           <a:p>
             <a:pPr lvl="3"/>
             <a:r>
-              <a:rPr lang="en-US" smtClean="0"/>
+              <a:rPr lang="en-US"/>
               <a:t>Fourth level</a:t>
             </a:r>
           </a:p>
           <a:p>
             <a:pPr lvl="4"/>
             <a:r>
-              <a:rPr lang="en-US" smtClean="0"/>
+              <a:rPr lang="en-US"/>
               <a:t>Fifth level</a:t>
             </a:r>
             <a:endParaRPr lang="en-GB"/>
@@ -458,7 +474,7 @@
           <a:p>
             <a:fld id="{6BA5D40C-A8DC-479A-A5D3-E7B4936A184B}" type="datetimeFigureOut">
               <a:rPr lang="en-GB" smtClean="0"/>
-              <a:t>15/07/2015</a:t>
+              <a:t>20/05/2026</a:t>
             </a:fld>
             <a:endParaRPr lang="en-GB"/>
           </a:p>
@@ -557,7 +573,7 @@
           <a:lstStyle/>
           <a:p>
             <a:r>
-              <a:rPr lang="en-US" smtClean="0"/>
+              <a:rPr lang="en-US"/>
               <a:t>Click to edit Master title style</a:t>
             </a:r>
             <a:endParaRPr lang="en-GB"/>
@@ -586,35 +602,35 @@
           <a:p>
             <a:pPr lvl="0"/>
             <a:r>
-              <a:rPr lang="en-US" smtClean="0"/>
+              <a:rPr lang="en-US"/>
               <a:t>Click to edit Master text styles</a:t>
             </a:r>
           </a:p>
           <a:p>
             <a:pPr lvl="1"/>
             <a:r>
-              <a:rPr lang="en-US" smtClean="0"/>
+              <a:rPr lang="en-US"/>
               <a:t>Second level</a:t>
             </a:r>
           </a:p>
           <a:p>
             <a:pPr lvl="2"/>
             <a:r>
-              <a:rPr lang="en-US" smtClean="0"/>
+              <a:rPr lang="en-US"/>
               <a:t>Third level</a:t>
             </a:r>
           </a:p>
           <a:p>
             <a:pPr lvl="3"/>
             <a:r>
-              <a:rPr lang="en-US" smtClean="0"/>
+              <a:rPr lang="en-US"/>
               <a:t>Fourth level</a:t>
             </a:r>
           </a:p>
           <a:p>
             <a:pPr lvl="4"/>
             <a:r>
-              <a:rPr lang="en-US" smtClean="0"/>
+              <a:rPr lang="en-US"/>
               <a:t>Fifth level</a:t>
             </a:r>
             <a:endParaRPr lang="en-GB"/>
@@ -638,7 +654,7 @@
           <a:p>
             <a:fld id="{6BA5D40C-A8DC-479A-A5D3-E7B4936A184B}" type="datetimeFigureOut">
               <a:rPr lang="en-GB" smtClean="0"/>
-              <a:t>15/07/2015</a:t>
+              <a:t>20/05/2026</a:t>
             </a:fld>
             <a:endParaRPr lang="en-GB"/>
           </a:p>
@@ -732,7 +748,7 @@
           <a:lstStyle/>
           <a:p>
             <a:r>
-              <a:rPr lang="en-US" smtClean="0"/>
+              <a:rPr lang="en-US"/>
               <a:t>Click to edit Master title style</a:t>
             </a:r>
             <a:endParaRPr lang="en-GB"/>
@@ -756,35 +772,35 @@
           <a:p>
             <a:pPr lvl="0"/>
             <a:r>
-              <a:rPr lang="en-US" smtClean="0"/>
+              <a:rPr lang="en-US"/>
               <a:t>Click to edit Master text styles</a:t>
             </a:r>
           </a:p>
           <a:p>
             <a:pPr lvl="1"/>
             <a:r>
-              <a:rPr lang="en-US" smtClean="0"/>
+              <a:rPr lang="en-US"/>
               <a:t>Second level</a:t>
             </a:r>
           </a:p>
           <a:p>
             <a:pPr lvl="2"/>
             <a:r>
-              <a:rPr lang="en-US" smtClean="0"/>
+              <a:rPr lang="en-US"/>
               <a:t>Third level</a:t>
             </a:r>
           </a:p>
           <a:p>
             <a:pPr lvl="3"/>
             <a:r>
-              <a:rPr lang="en-US" smtClean="0"/>
+              <a:rPr lang="en-US"/>
               <a:t>Fourth level</a:t>
             </a:r>
           </a:p>
           <a:p>
             <a:pPr lvl="4"/>
             <a:r>
-              <a:rPr lang="en-US" smtClean="0"/>
+              <a:rPr lang="en-US"/>
               <a:t>Fifth level</a:t>
             </a:r>
             <a:endParaRPr lang="en-GB"/>
@@ -808,7 +824,7 @@
           <a:p>
             <a:fld id="{6BA5D40C-A8DC-479A-A5D3-E7B4936A184B}" type="datetimeFigureOut">
               <a:rPr lang="en-GB" smtClean="0"/>
-              <a:t>15/07/2015</a:t>
+              <a:t>20/05/2026</a:t>
             </a:fld>
             <a:endParaRPr lang="en-GB"/>
           </a:p>
@@ -911,7 +927,7 @@
           </a:lstStyle>
           <a:p>
             <a:r>
-              <a:rPr lang="en-US" smtClean="0"/>
+              <a:rPr lang="en-US"/>
               <a:t>Click to edit Master title style</a:t>
             </a:r>
             <a:endParaRPr lang="en-GB"/>
@@ -1031,7 +1047,7 @@
           <a:p>
             <a:pPr lvl="0"/>
             <a:r>
-              <a:rPr lang="en-US" smtClean="0"/>
+              <a:rPr lang="en-US"/>
               <a:t>Click to edit Master text styles</a:t>
             </a:r>
           </a:p>
@@ -1054,7 +1070,7 @@
           <a:p>
             <a:fld id="{6BA5D40C-A8DC-479A-A5D3-E7B4936A184B}" type="datetimeFigureOut">
               <a:rPr lang="en-GB" smtClean="0"/>
-              <a:t>15/07/2015</a:t>
+              <a:t>20/05/2026</a:t>
             </a:fld>
             <a:endParaRPr lang="en-GB"/>
           </a:p>
@@ -1148,7 +1164,7 @@
           <a:lstStyle/>
           <a:p>
             <a:r>
-              <a:rPr lang="en-US" smtClean="0"/>
+              <a:rPr lang="en-US"/>
               <a:t>Click to edit Master title style</a:t>
             </a:r>
             <a:endParaRPr lang="en-GB"/>
@@ -1205,35 +1221,35 @@
           <a:p>
             <a:pPr lvl="0"/>
             <a:r>
-              <a:rPr lang="en-US" smtClean="0"/>
+              <a:rPr lang="en-US"/>
               <a:t>Click to edit Master text styles</a:t>
             </a:r>
           </a:p>
           <a:p>
             <a:pPr lvl="1"/>
             <a:r>
-              <a:rPr lang="en-US" smtClean="0"/>
+              <a:rPr lang="en-US"/>
               <a:t>Second level</a:t>
             </a:r>
           </a:p>
           <a:p>
             <a:pPr lvl="2"/>
             <a:r>
-              <a:rPr lang="en-US" smtClean="0"/>
+              <a:rPr lang="en-US"/>
               <a:t>Third level</a:t>
             </a:r>
           </a:p>
           <a:p>
             <a:pPr lvl="3"/>
             <a:r>
-              <a:rPr lang="en-US" smtClean="0"/>
+              <a:rPr lang="en-US"/>
               <a:t>Fourth level</a:t>
             </a:r>
           </a:p>
           <a:p>
             <a:pPr lvl="4"/>
             <a:r>
-              <a:rPr lang="en-US" smtClean="0"/>
+              <a:rPr lang="en-US"/>
               <a:t>Fifth level</a:t>
             </a:r>
             <a:endParaRPr lang="en-GB"/>
@@ -1290,35 +1306,35 @@
           <a:p>
             <a:pPr lvl="0"/>
             <a:r>
-              <a:rPr lang="en-US" smtClean="0"/>
+              <a:rPr lang="en-US"/>
               <a:t>Click to edit Master text styles</a:t>
             </a:r>
           </a:p>
           <a:p>
             <a:pPr lvl="1"/>
             <a:r>
-              <a:rPr lang="en-US" smtClean="0"/>
+              <a:rPr lang="en-US"/>
               <a:t>Second level</a:t>
             </a:r>
           </a:p>
           <a:p>
             <a:pPr lvl="2"/>
             <a:r>
-              <a:rPr lang="en-US" smtClean="0"/>
+              <a:rPr lang="en-US"/>
               <a:t>Third level</a:t>
             </a:r>
           </a:p>
           <a:p>
             <a:pPr lvl="3"/>
             <a:r>
-              <a:rPr lang="en-US" smtClean="0"/>
+              <a:rPr lang="en-US"/>
               <a:t>Fourth level</a:t>
             </a:r>
           </a:p>
           <a:p>
             <a:pPr lvl="4"/>
             <a:r>
-              <a:rPr lang="en-US" smtClean="0"/>
+              <a:rPr lang="en-US"/>
               <a:t>Fifth level</a:t>
             </a:r>
             <a:endParaRPr lang="en-GB"/>
@@ -1342,7 +1358,7 @@
           <a:p>
             <a:fld id="{6BA5D40C-A8DC-479A-A5D3-E7B4936A184B}" type="datetimeFigureOut">
               <a:rPr lang="en-GB" smtClean="0"/>
-              <a:t>15/07/2015</a:t>
+              <a:t>20/05/2026</a:t>
             </a:fld>
             <a:endParaRPr lang="en-GB"/>
           </a:p>
@@ -1445,7 +1461,7 @@
           </a:lstStyle>
           <a:p>
             <a:r>
-              <a:rPr lang="en-US" smtClean="0"/>
+              <a:rPr lang="en-US"/>
               <a:t>Click to edit Master title style</a:t>
             </a:r>
             <a:endParaRPr lang="en-GB"/>
@@ -1511,7 +1527,7 @@
           <a:p>
             <a:pPr lvl="0"/>
             <a:r>
-              <a:rPr lang="en-US" smtClean="0"/>
+              <a:rPr lang="en-US"/>
               <a:t>Click to edit Master text styles</a:t>
             </a:r>
           </a:p>
@@ -1567,35 +1583,35 @@
           <a:p>
             <a:pPr lvl="0"/>
             <a:r>
-              <a:rPr lang="en-US" smtClean="0"/>
+              <a:rPr lang="en-US"/>
               <a:t>Click to edit Master text styles</a:t>
             </a:r>
           </a:p>
           <a:p>
             <a:pPr lvl="1"/>
             <a:r>
-              <a:rPr lang="en-US" smtClean="0"/>
+              <a:rPr lang="en-US"/>
               <a:t>Second level</a:t>
             </a:r>
           </a:p>
           <a:p>
             <a:pPr lvl="2"/>
             <a:r>
-              <a:rPr lang="en-US" smtClean="0"/>
+              <a:rPr lang="en-US"/>
               <a:t>Third level</a:t>
             </a:r>
           </a:p>
           <a:p>
             <a:pPr lvl="3"/>
             <a:r>
-              <a:rPr lang="en-US" smtClean="0"/>
+              <a:rPr lang="en-US"/>
               <a:t>Fourth level</a:t>
             </a:r>
           </a:p>
           <a:p>
             <a:pPr lvl="4"/>
             <a:r>
-              <a:rPr lang="en-US" smtClean="0"/>
+              <a:rPr lang="en-US"/>
               <a:t>Fifth level</a:t>
             </a:r>
             <a:endParaRPr lang="en-GB"/>
@@ -1661,7 +1677,7 @@
           <a:p>
             <a:pPr lvl="0"/>
             <a:r>
-              <a:rPr lang="en-US" smtClean="0"/>
+              <a:rPr lang="en-US"/>
               <a:t>Click to edit Master text styles</a:t>
             </a:r>
           </a:p>
@@ -1717,35 +1733,35 @@
           <a:p>
             <a:pPr lvl="0"/>
             <a:r>
-              <a:rPr lang="en-US" smtClean="0"/>
+              <a:rPr lang="en-US"/>
               <a:t>Click to edit Master text styles</a:t>
             </a:r>
           </a:p>
           <a:p>
             <a:pPr lvl="1"/>
             <a:r>
-              <a:rPr lang="en-US" smtClean="0"/>
+              <a:rPr lang="en-US"/>
               <a:t>Second level</a:t>
             </a:r>
           </a:p>
           <a:p>
             <a:pPr lvl="2"/>
             <a:r>
-              <a:rPr lang="en-US" smtClean="0"/>
+              <a:rPr lang="en-US"/>
               <a:t>Third level</a:t>
             </a:r>
           </a:p>
           <a:p>
             <a:pPr lvl="3"/>
             <a:r>
-              <a:rPr lang="en-US" smtClean="0"/>
+              <a:rPr lang="en-US"/>
               <a:t>Fourth level</a:t>
             </a:r>
           </a:p>
           <a:p>
             <a:pPr lvl="4"/>
             <a:r>
-              <a:rPr lang="en-US" smtClean="0"/>
+              <a:rPr lang="en-US"/>
               <a:t>Fifth level</a:t>
             </a:r>
             <a:endParaRPr lang="en-GB"/>
@@ -1769,7 +1785,7 @@
           <a:p>
             <a:fld id="{6BA5D40C-A8DC-479A-A5D3-E7B4936A184B}" type="datetimeFigureOut">
               <a:rPr lang="en-GB" smtClean="0"/>
-              <a:t>15/07/2015</a:t>
+              <a:t>20/05/2026</a:t>
             </a:fld>
             <a:endParaRPr lang="en-GB"/>
           </a:p>
@@ -1863,7 +1879,7 @@
           <a:lstStyle/>
           <a:p>
             <a:r>
-              <a:rPr lang="en-US" smtClean="0"/>
+              <a:rPr lang="en-US"/>
               <a:t>Click to edit Master title style</a:t>
             </a:r>
             <a:endParaRPr lang="en-GB"/>
@@ -1887,7 +1903,7 @@
           <a:p>
             <a:fld id="{6BA5D40C-A8DC-479A-A5D3-E7B4936A184B}" type="datetimeFigureOut">
               <a:rPr lang="en-GB" smtClean="0"/>
-              <a:t>15/07/2015</a:t>
+              <a:t>20/05/2026</a:t>
             </a:fld>
             <a:endParaRPr lang="en-GB"/>
           </a:p>
@@ -1982,7 +1998,7 @@
           <a:p>
             <a:fld id="{6BA5D40C-A8DC-479A-A5D3-E7B4936A184B}" type="datetimeFigureOut">
               <a:rPr lang="en-GB" smtClean="0"/>
-              <a:t>15/07/2015</a:t>
+              <a:t>20/05/2026</a:t>
             </a:fld>
             <a:endParaRPr lang="en-GB"/>
           </a:p>
@@ -2085,7 +2101,7 @@
           </a:lstStyle>
           <a:p>
             <a:r>
-              <a:rPr lang="en-US" smtClean="0"/>
+              <a:rPr lang="en-US"/>
               <a:t>Click to edit Master title style</a:t>
             </a:r>
             <a:endParaRPr lang="en-GB"/>
@@ -2142,35 +2158,35 @@
           <a:p>
             <a:pPr lvl="0"/>
             <a:r>
-              <a:rPr lang="en-US" smtClean="0"/>
+              <a:rPr lang="en-US"/>
               <a:t>Click to edit Master text styles</a:t>
             </a:r>
           </a:p>
           <a:p>
             <a:pPr lvl="1"/>
             <a:r>
-              <a:rPr lang="en-US" smtClean="0"/>
+              <a:rPr lang="en-US"/>
               <a:t>Second level</a:t>
             </a:r>
           </a:p>
           <a:p>
             <a:pPr lvl="2"/>
             <a:r>
-              <a:rPr lang="en-US" smtClean="0"/>
+              <a:rPr lang="en-US"/>
               <a:t>Third level</a:t>
             </a:r>
           </a:p>
           <a:p>
             <a:pPr lvl="3"/>
             <a:r>
-              <a:rPr lang="en-US" smtClean="0"/>
+              <a:rPr lang="en-US"/>
               <a:t>Fourth level</a:t>
             </a:r>
           </a:p>
           <a:p>
             <a:pPr lvl="4"/>
             <a:r>
-              <a:rPr lang="en-US" smtClean="0"/>
+              <a:rPr lang="en-US"/>
               <a:t>Fifth level</a:t>
             </a:r>
             <a:endParaRPr lang="en-GB"/>
@@ -2236,7 +2252,7 @@
           <a:p>
             <a:pPr lvl="0"/>
             <a:r>
-              <a:rPr lang="en-US" smtClean="0"/>
+              <a:rPr lang="en-US"/>
               <a:t>Click to edit Master text styles</a:t>
             </a:r>
           </a:p>
@@ -2259,7 +2275,7 @@
           <a:p>
             <a:fld id="{6BA5D40C-A8DC-479A-A5D3-E7B4936A184B}" type="datetimeFigureOut">
               <a:rPr lang="en-GB" smtClean="0"/>
-              <a:t>15/07/2015</a:t>
+              <a:t>20/05/2026</a:t>
             </a:fld>
             <a:endParaRPr lang="en-GB"/>
           </a:p>
@@ -2362,7 +2378,7 @@
           </a:lstStyle>
           <a:p>
             <a:r>
-              <a:rPr lang="en-US" smtClean="0"/>
+              <a:rPr lang="en-US"/>
               <a:t>Click to edit Master title style</a:t>
             </a:r>
             <a:endParaRPr lang="en-GB"/>
@@ -2489,7 +2505,7 @@
           <a:p>
             <a:pPr lvl="0"/>
             <a:r>
-              <a:rPr lang="en-US" smtClean="0"/>
+              <a:rPr lang="en-US"/>
               <a:t>Click to edit Master text styles</a:t>
             </a:r>
           </a:p>
@@ -2512,7 +2528,7 @@
           <a:p>
             <a:fld id="{6BA5D40C-A8DC-479A-A5D3-E7B4936A184B}" type="datetimeFigureOut">
               <a:rPr lang="en-GB" smtClean="0"/>
-              <a:t>15/07/2015</a:t>
+              <a:t>20/05/2026</a:t>
             </a:fld>
             <a:endParaRPr lang="en-GB"/>
           </a:p>
@@ -2621,7 +2637,7 @@
           <a:lstStyle/>
           <a:p>
             <a:r>
-              <a:rPr lang="en-US" smtClean="0"/>
+              <a:rPr lang="en-US"/>
               <a:t>Click to edit Master title style</a:t>
             </a:r>
             <a:endParaRPr lang="en-GB"/>
@@ -2655,35 +2671,35 @@
           <a:p>
             <a:pPr lvl="0"/>
             <a:r>
-              <a:rPr lang="en-US" smtClean="0"/>
+              <a:rPr lang="en-US"/>
               <a:t>Click to edit Master text styles</a:t>
             </a:r>
           </a:p>
           <a:p>
             <a:pPr lvl="1"/>
             <a:r>
-              <a:rPr lang="en-US" smtClean="0"/>
+              <a:rPr lang="en-US"/>
               <a:t>Second level</a:t>
             </a:r>
           </a:p>
           <a:p>
             <a:pPr lvl="2"/>
             <a:r>
-              <a:rPr lang="en-US" smtClean="0"/>
+              <a:rPr lang="en-US"/>
               <a:t>Third level</a:t>
             </a:r>
           </a:p>
           <a:p>
             <a:pPr lvl="3"/>
             <a:r>
-              <a:rPr lang="en-US" smtClean="0"/>
+              <a:rPr lang="en-US"/>
               <a:t>Fourth level</a:t>
             </a:r>
           </a:p>
           <a:p>
             <a:pPr lvl="4"/>
             <a:r>
-              <a:rPr lang="en-US" smtClean="0"/>
+              <a:rPr lang="en-US"/>
               <a:t>Fifth level</a:t>
             </a:r>
             <a:endParaRPr lang="en-GB"/>
@@ -2725,7 +2741,7 @@
           <a:p>
             <a:fld id="{6BA5D40C-A8DC-479A-A5D3-E7B4936A184B}" type="datetimeFigureOut">
               <a:rPr lang="en-GB" smtClean="0"/>
-              <a:t>15/07/2015</a:t>
+              <a:t>20/05/2026</a:t>
             </a:fld>
             <a:endParaRPr lang="en-GB"/>
           </a:p>
@@ -3100,9 +3116,9 @@
           <a:chExt cx="0" cy="0"/>
         </a:xfrm>
       </p:grpSpPr>
-      <p:grpSp xmlns:pic="http://schemas.openxmlformats.org/drawingml/2006/picture">
+      <p:grpSp>
         <p:nvGrpSpPr>
-          <p:cNvPr id="2" name=""/>
+          <p:cNvPr id="2" name="Group 1"/>
           <p:cNvGrpSpPr/>
           <p:nvPr/>
         </p:nvGrpSpPr>
@@ -3146,7 +3162,9 @@
           <p:txBody>
             <a:bodyPr/>
             <a:lstStyle/>
-            <a:p/>
+            <a:p>
+              <a:endParaRPr/>
+            </a:p>
           </p:txBody>
         </p:sp>
         <p:sp>
@@ -3181,7 +3199,9 @@
           <p:txBody>
             <a:bodyPr/>
             <a:lstStyle/>
-            <a:p/>
+            <a:p>
+              <a:endParaRPr/>
+            </a:p>
           </p:txBody>
         </p:sp>
         <p:sp>
@@ -3207,7 +3227,9 @@
           <p:txBody>
             <a:bodyPr/>
             <a:lstStyle/>
-            <a:p/>
+            <a:p>
+              <a:endParaRPr/>
+            </a:p>
           </p:txBody>
         </p:sp>
         <p:sp>
@@ -3223,8 +3245,12 @@
             </a:xfrm>
             <a:custGeom>
               <a:avLst/>
+              <a:gdLst/>
+              <a:ahLst/>
+              <a:cxnLst/>
+              <a:rect l="0" t="0" r="0" b="0"/>
               <a:pathLst>
-                <a:path w="3587697" h="0">
+                <a:path w="3587697">
                   <a:moveTo>
                     <a:pt x="0" y="0"/>
                   </a:moveTo>
@@ -3250,7 +3276,9 @@
           <p:txBody>
             <a:bodyPr/>
             <a:lstStyle/>
-            <a:p/>
+            <a:p>
+              <a:endParaRPr/>
+            </a:p>
           </p:txBody>
         </p:sp>
         <p:sp>
@@ -3266,8 +3294,12 @@
             </a:xfrm>
             <a:custGeom>
               <a:avLst/>
+              <a:gdLst/>
+              <a:ahLst/>
+              <a:cxnLst/>
+              <a:rect l="0" t="0" r="0" b="0"/>
               <a:pathLst>
-                <a:path w="3587697" h="0">
+                <a:path w="3587697">
                   <a:moveTo>
                     <a:pt x="0" y="0"/>
                   </a:moveTo>
@@ -3293,7 +3325,9 @@
           <p:txBody>
             <a:bodyPr/>
             <a:lstStyle/>
-            <a:p/>
+            <a:p>
+              <a:endParaRPr/>
+            </a:p>
           </p:txBody>
         </p:sp>
         <p:sp>
@@ -3309,8 +3343,12 @@
             </a:xfrm>
             <a:custGeom>
               <a:avLst/>
+              <a:gdLst/>
+              <a:ahLst/>
+              <a:cxnLst/>
+              <a:rect l="0" t="0" r="0" b="0"/>
               <a:pathLst>
-                <a:path w="3587697" h="0">
+                <a:path w="3587697">
                   <a:moveTo>
                     <a:pt x="0" y="0"/>
                   </a:moveTo>
@@ -3336,7 +3374,9 @@
           <p:txBody>
             <a:bodyPr/>
             <a:lstStyle/>
-            <a:p/>
+            <a:p>
+              <a:endParaRPr/>
+            </a:p>
           </p:txBody>
         </p:sp>
         <p:sp>
@@ -3352,8 +3392,12 @@
             </a:xfrm>
             <a:custGeom>
               <a:avLst/>
+              <a:gdLst/>
+              <a:ahLst/>
+              <a:cxnLst/>
+              <a:rect l="0" t="0" r="0" b="0"/>
               <a:pathLst>
-                <a:path w="3587697" h="0">
+                <a:path w="3587697">
                   <a:moveTo>
                     <a:pt x="0" y="0"/>
                   </a:moveTo>
@@ -3379,7 +3423,9 @@
           <p:txBody>
             <a:bodyPr/>
             <a:lstStyle/>
-            <a:p/>
+            <a:p>
+              <a:endParaRPr/>
+            </a:p>
           </p:txBody>
         </p:sp>
         <p:sp>
@@ -3395,8 +3441,12 @@
             </a:xfrm>
             <a:custGeom>
               <a:avLst/>
+              <a:gdLst/>
+              <a:ahLst/>
+              <a:cxnLst/>
+              <a:rect l="0" t="0" r="0" b="0"/>
               <a:pathLst>
-                <a:path w="3587697" h="0">
+                <a:path w="3587697">
                   <a:moveTo>
                     <a:pt x="0" y="0"/>
                   </a:moveTo>
@@ -3422,7 +3472,9 @@
           <p:txBody>
             <a:bodyPr/>
             <a:lstStyle/>
-            <a:p/>
+            <a:p>
+              <a:endParaRPr/>
+            </a:p>
           </p:txBody>
         </p:sp>
         <p:sp>
@@ -3438,8 +3490,12 @@
             </a:xfrm>
             <a:custGeom>
               <a:avLst/>
+              <a:gdLst/>
+              <a:ahLst/>
+              <a:cxnLst/>
+              <a:rect l="0" t="0" r="0" b="0"/>
               <a:pathLst>
-                <a:path w="3587697" h="0">
+                <a:path w="3587697">
                   <a:moveTo>
                     <a:pt x="0" y="0"/>
                   </a:moveTo>
@@ -3465,7 +3521,9 @@
           <p:txBody>
             <a:bodyPr/>
             <a:lstStyle/>
-            <a:p/>
+            <a:p>
+              <a:endParaRPr/>
+            </a:p>
           </p:txBody>
         </p:sp>
         <p:sp>
@@ -3481,8 +3539,12 @@
             </a:xfrm>
             <a:custGeom>
               <a:avLst/>
+              <a:gdLst/>
+              <a:ahLst/>
+              <a:cxnLst/>
+              <a:rect l="0" t="0" r="0" b="0"/>
               <a:pathLst>
-                <a:path w="3587697" h="0">
+                <a:path w="3587697">
                   <a:moveTo>
                     <a:pt x="0" y="0"/>
                   </a:moveTo>
@@ -3508,7 +3570,9 @@
           <p:txBody>
             <a:bodyPr/>
             <a:lstStyle/>
-            <a:p/>
+            <a:p>
+              <a:endParaRPr/>
+            </a:p>
           </p:txBody>
         </p:sp>
         <p:sp>
@@ -3519,13 +3583,17 @@
           </p:nvSpPr>
           <p:spPr>
             <a:xfrm>
-              <a:off x="3925639" y="1565014"/>
+              <a:off x="3900788" y="1565014"/>
               <a:ext cx="0" cy="2786288"/>
             </a:xfrm>
             <a:custGeom>
               <a:avLst/>
+              <a:gdLst/>
+              <a:ahLst/>
+              <a:cxnLst/>
+              <a:rect l="0" t="0" r="0" b="0"/>
               <a:pathLst>
-                <a:path w="0" h="2786288">
+                <a:path h="2786288">
                   <a:moveTo>
                     <a:pt x="0" y="2786288"/>
                   </a:moveTo>
@@ -3551,7 +3619,9 @@
           <p:txBody>
             <a:bodyPr/>
             <a:lstStyle/>
-            <a:p/>
+            <a:p>
+              <a:endParaRPr/>
+            </a:p>
           </p:txBody>
         </p:sp>
         <p:sp>
@@ -3562,13 +3632,17 @@
           </p:nvSpPr>
           <p:spPr>
             <a:xfrm>
-              <a:off x="4219712" y="1565014"/>
+              <a:off x="4153442" y="1565014"/>
               <a:ext cx="0" cy="2786288"/>
             </a:xfrm>
             <a:custGeom>
               <a:avLst/>
+              <a:gdLst/>
+              <a:ahLst/>
+              <a:cxnLst/>
+              <a:rect l="0" t="0" r="0" b="0"/>
               <a:pathLst>
-                <a:path w="0" h="2786288">
+                <a:path h="2786288">
                   <a:moveTo>
                     <a:pt x="0" y="2786288"/>
                   </a:moveTo>
@@ -3594,7 +3668,9 @@
           <p:txBody>
             <a:bodyPr/>
             <a:lstStyle/>
-            <a:p/>
+            <a:p>
+              <a:endParaRPr/>
+            </a:p>
           </p:txBody>
         </p:sp>
         <p:sp>
@@ -3605,13 +3681,17 @@
           </p:nvSpPr>
           <p:spPr>
             <a:xfrm>
-              <a:off x="4513786" y="1565014"/>
+              <a:off x="4406097" y="1565014"/>
               <a:ext cx="0" cy="2786288"/>
             </a:xfrm>
             <a:custGeom>
               <a:avLst/>
+              <a:gdLst/>
+              <a:ahLst/>
+              <a:cxnLst/>
+              <a:rect l="0" t="0" r="0" b="0"/>
               <a:pathLst>
-                <a:path w="0" h="2786288">
+                <a:path h="2786288">
                   <a:moveTo>
                     <a:pt x="0" y="2786288"/>
                   </a:moveTo>
@@ -3637,7 +3717,9 @@
           <p:txBody>
             <a:bodyPr/>
             <a:lstStyle/>
-            <a:p/>
+            <a:p>
+              <a:endParaRPr/>
+            </a:p>
           </p:txBody>
         </p:sp>
         <p:sp>
@@ -3648,13 +3730,17 @@
           </p:nvSpPr>
           <p:spPr>
             <a:xfrm>
-              <a:off x="4807860" y="1565014"/>
+              <a:off x="4658752" y="1565014"/>
               <a:ext cx="0" cy="2786288"/>
             </a:xfrm>
             <a:custGeom>
               <a:avLst/>
+              <a:gdLst/>
+              <a:ahLst/>
+              <a:cxnLst/>
+              <a:rect l="0" t="0" r="0" b="0"/>
               <a:pathLst>
-                <a:path w="0" h="2786288">
+                <a:path h="2786288">
                   <a:moveTo>
                     <a:pt x="0" y="2786288"/>
                   </a:moveTo>
@@ -3680,7 +3766,9 @@
           <p:txBody>
             <a:bodyPr/>
             <a:lstStyle/>
-            <a:p/>
+            <a:p>
+              <a:endParaRPr/>
+            </a:p>
           </p:txBody>
         </p:sp>
         <p:sp>
@@ -3691,13 +3779,17 @@
           </p:nvSpPr>
           <p:spPr>
             <a:xfrm>
-              <a:off x="5101933" y="1565014"/>
+              <a:off x="4911407" y="1565014"/>
               <a:ext cx="0" cy="2786288"/>
             </a:xfrm>
             <a:custGeom>
               <a:avLst/>
+              <a:gdLst/>
+              <a:ahLst/>
+              <a:cxnLst/>
+              <a:rect l="0" t="0" r="0" b="0"/>
               <a:pathLst>
-                <a:path w="0" h="2786288">
+                <a:path h="2786288">
                   <a:moveTo>
                     <a:pt x="0" y="2786288"/>
                   </a:moveTo>
@@ -3723,7 +3815,9 @@
           <p:txBody>
             <a:bodyPr/>
             <a:lstStyle/>
-            <a:p/>
+            <a:p>
+              <a:endParaRPr/>
+            </a:p>
           </p:txBody>
         </p:sp>
         <p:sp>
@@ -3734,13 +3828,17 @@
           </p:nvSpPr>
           <p:spPr>
             <a:xfrm>
-              <a:off x="5396007" y="1565014"/>
+              <a:off x="5164061" y="1565014"/>
               <a:ext cx="0" cy="2786288"/>
             </a:xfrm>
             <a:custGeom>
               <a:avLst/>
+              <a:gdLst/>
+              <a:ahLst/>
+              <a:cxnLst/>
+              <a:rect l="0" t="0" r="0" b="0"/>
               <a:pathLst>
-                <a:path w="0" h="2786288">
+                <a:path h="2786288">
                   <a:moveTo>
                     <a:pt x="0" y="2786288"/>
                   </a:moveTo>
@@ -3766,7 +3864,9 @@
           <p:txBody>
             <a:bodyPr/>
             <a:lstStyle/>
-            <a:p/>
+            <a:p>
+              <a:endParaRPr/>
+            </a:p>
           </p:txBody>
         </p:sp>
         <p:sp>
@@ -3777,13 +3877,17 @@
           </p:nvSpPr>
           <p:spPr>
             <a:xfrm>
-              <a:off x="5690080" y="1565014"/>
+              <a:off x="5416716" y="1565014"/>
               <a:ext cx="0" cy="2786288"/>
             </a:xfrm>
             <a:custGeom>
               <a:avLst/>
+              <a:gdLst/>
+              <a:ahLst/>
+              <a:cxnLst/>
+              <a:rect l="0" t="0" r="0" b="0"/>
               <a:pathLst>
-                <a:path w="0" h="2786288">
+                <a:path h="2786288">
                   <a:moveTo>
                     <a:pt x="0" y="2786288"/>
                   </a:moveTo>
@@ -3809,7 +3913,9 @@
           <p:txBody>
             <a:bodyPr/>
             <a:lstStyle/>
-            <a:p/>
+            <a:p>
+              <a:endParaRPr/>
+            </a:p>
           </p:txBody>
         </p:sp>
         <p:sp>
@@ -3820,13 +3926,17 @@
           </p:nvSpPr>
           <p:spPr>
             <a:xfrm>
-              <a:off x="5984154" y="1565014"/>
+              <a:off x="5669371" y="1565014"/>
               <a:ext cx="0" cy="2786288"/>
             </a:xfrm>
             <a:custGeom>
               <a:avLst/>
+              <a:gdLst/>
+              <a:ahLst/>
+              <a:cxnLst/>
+              <a:rect l="0" t="0" r="0" b="0"/>
               <a:pathLst>
-                <a:path w="0" h="2786288">
+                <a:path h="2786288">
                   <a:moveTo>
                     <a:pt x="0" y="2786288"/>
                   </a:moveTo>
@@ -3852,7 +3962,9 @@
           <p:txBody>
             <a:bodyPr/>
             <a:lstStyle/>
-            <a:p/>
+            <a:p>
+              <a:endParaRPr/>
+            </a:p>
           </p:txBody>
         </p:sp>
         <p:sp>
@@ -3863,13 +3975,17 @@
           </p:nvSpPr>
           <p:spPr>
             <a:xfrm>
-              <a:off x="6278227" y="1565014"/>
+              <a:off x="5922025" y="1565014"/>
               <a:ext cx="0" cy="2786288"/>
             </a:xfrm>
             <a:custGeom>
               <a:avLst/>
+              <a:gdLst/>
+              <a:ahLst/>
+              <a:cxnLst/>
+              <a:rect l="0" t="0" r="0" b="0"/>
               <a:pathLst>
-                <a:path w="0" h="2786288">
+                <a:path h="2786288">
                   <a:moveTo>
                     <a:pt x="0" y="2786288"/>
                   </a:moveTo>
@@ -3895,7 +4011,9 @@
           <p:txBody>
             <a:bodyPr/>
             <a:lstStyle/>
-            <a:p/>
+            <a:p>
+              <a:endParaRPr/>
+            </a:p>
           </p:txBody>
         </p:sp>
         <p:sp>
@@ -3906,13 +4024,17 @@
           </p:nvSpPr>
           <p:spPr>
             <a:xfrm>
-              <a:off x="6572301" y="1565014"/>
+              <a:off x="6174680" y="1565014"/>
               <a:ext cx="0" cy="2786288"/>
             </a:xfrm>
             <a:custGeom>
               <a:avLst/>
+              <a:gdLst/>
+              <a:ahLst/>
+              <a:cxnLst/>
+              <a:rect l="0" t="0" r="0" b="0"/>
               <a:pathLst>
-                <a:path w="0" h="2786288">
+                <a:path h="2786288">
                   <a:moveTo>
                     <a:pt x="0" y="2786288"/>
                   </a:moveTo>
@@ -3938,7 +4060,9 @@
           <p:txBody>
             <a:bodyPr/>
             <a:lstStyle/>
-            <a:p/>
+            <a:p>
+              <a:endParaRPr/>
+            </a:p>
           </p:txBody>
         </p:sp>
         <p:sp>
@@ -3949,13 +4073,17 @@
           </p:nvSpPr>
           <p:spPr>
             <a:xfrm>
-              <a:off x="6866374" y="1565014"/>
+              <a:off x="6427335" y="1565014"/>
               <a:ext cx="0" cy="2786288"/>
             </a:xfrm>
             <a:custGeom>
               <a:avLst/>
+              <a:gdLst/>
+              <a:ahLst/>
+              <a:cxnLst/>
+              <a:rect l="0" t="0" r="0" b="0"/>
               <a:pathLst>
-                <a:path w="0" h="2786288">
+                <a:path h="2786288">
                   <a:moveTo>
                     <a:pt x="0" y="2786288"/>
                   </a:moveTo>
@@ -3981,7 +4109,9 @@
           <p:txBody>
             <a:bodyPr/>
             <a:lstStyle/>
-            <a:p/>
+            <a:p>
+              <a:endParaRPr/>
+            </a:p>
           </p:txBody>
         </p:sp>
         <p:sp>
@@ -3992,13 +4122,17 @@
           </p:nvSpPr>
           <p:spPr>
             <a:xfrm>
-              <a:off x="7160448" y="1565014"/>
+              <a:off x="6679990" y="1565014"/>
               <a:ext cx="0" cy="2786288"/>
             </a:xfrm>
             <a:custGeom>
               <a:avLst/>
+              <a:gdLst/>
+              <a:ahLst/>
+              <a:cxnLst/>
+              <a:rect l="0" t="0" r="0" b="0"/>
               <a:pathLst>
-                <a:path w="0" h="2786288">
+                <a:path h="2786288">
                   <a:moveTo>
                     <a:pt x="0" y="2786288"/>
                   </a:moveTo>
@@ -4024,7 +4158,9 @@
           <p:txBody>
             <a:bodyPr/>
             <a:lstStyle/>
-            <a:p/>
+            <a:p>
+              <a:endParaRPr/>
+            </a:p>
           </p:txBody>
         </p:sp>
         <p:sp>
@@ -4035,25 +4171,32 @@
           </p:nvSpPr>
           <p:spPr>
             <a:xfrm>
-              <a:off x="3861785" y="4224653"/>
-              <a:ext cx="127708" cy="0"/>
+              <a:off x="6932644" y="1565014"/>
+              <a:ext cx="0" cy="2786288"/>
             </a:xfrm>
             <a:custGeom>
               <a:avLst/>
+              <a:gdLst/>
+              <a:ahLst/>
+              <a:cxnLst/>
+              <a:rect l="0" t="0" r="0" b="0"/>
               <a:pathLst>
-                <a:path w="127708" h="0">
+                <a:path h="2786288">
                   <a:moveTo>
+                    <a:pt x="0" y="2786288"/>
+                  </a:moveTo>
+                  <a:lnTo>
                     <a:pt x="0" y="0"/>
-                  </a:moveTo>
-                  <a:lnTo>
-                    <a:pt x="127708" y="0"/>
+                  </a:lnTo>
+                  <a:lnTo>
+                    <a:pt x="0" y="0"/>
                   </a:lnTo>
                 </a:path>
               </a:pathLst>
             </a:custGeom>
-            <a:ln w="9000" cap="rnd">
+            <a:ln w="13550" cap="flat">
               <a:solidFill>
-                <a:srgbClr val="007B82">
+                <a:srgbClr val="EBEBEB">
                   <a:alpha val="100000"/>
                 </a:srgbClr>
               </a:solidFill>
@@ -4064,7 +4207,9 @@
           <p:txBody>
             <a:bodyPr/>
             <a:lstStyle/>
-            <a:p/>
+            <a:p>
+              <a:endParaRPr/>
+            </a:p>
           </p:txBody>
         </p:sp>
         <p:sp>
@@ -4075,25 +4220,32 @@
           </p:nvSpPr>
           <p:spPr>
             <a:xfrm>
-              <a:off x="3925639" y="4160798"/>
-              <a:ext cx="0" cy="127708"/>
+              <a:off x="7185299" y="1565014"/>
+              <a:ext cx="0" cy="2786288"/>
             </a:xfrm>
             <a:custGeom>
               <a:avLst/>
+              <a:gdLst/>
+              <a:ahLst/>
+              <a:cxnLst/>
+              <a:rect l="0" t="0" r="0" b="0"/>
               <a:pathLst>
-                <a:path w="0" h="127708">
+                <a:path h="2786288">
                   <a:moveTo>
-                    <a:pt x="0" y="127708"/>
+                    <a:pt x="0" y="2786288"/>
                   </a:moveTo>
+                  <a:lnTo>
+                    <a:pt x="0" y="0"/>
+                  </a:lnTo>
                   <a:lnTo>
                     <a:pt x="0" y="0"/>
                   </a:lnTo>
                 </a:path>
               </a:pathLst>
             </a:custGeom>
-            <a:ln w="9000" cap="rnd">
+            <a:ln w="13550" cap="flat">
               <a:solidFill>
-                <a:srgbClr val="007B82">
+                <a:srgbClr val="EBEBEB">
                   <a:alpha val="100000"/>
                 </a:srgbClr>
               </a:solidFill>
@@ -4104,18 +4256,69 @@
           <p:txBody>
             <a:bodyPr/>
             <a:lstStyle/>
-            <a:p/>
-          </p:txBody>
-        </p:sp>
-        <p:sp>
-          <p:nvSpPr>
-            <p:cNvPr id="27" name="pt27"/>
+            <a:p>
+              <a:endParaRPr/>
+            </a:p>
+          </p:txBody>
+        </p:sp>
+        <p:sp>
+          <p:nvSpPr>
+            <p:cNvPr id="27" name="pg27"/>
             <p:cNvSpPr/>
             <p:nvPr/>
           </p:nvSpPr>
           <p:spPr>
             <a:xfrm>
-              <a:off x="4762708" y="2970574"/>
+              <a:off x="3855636" y="4179501"/>
+              <a:ext cx="90303" cy="90303"/>
+            </a:xfrm>
+            <a:custGeom>
+              <a:avLst/>
+              <a:gdLst/>
+              <a:ahLst/>
+              <a:cxnLst/>
+              <a:rect l="0" t="0" r="0" b="0"/>
+              <a:pathLst>
+                <a:path w="90303" h="90303">
+                  <a:moveTo>
+                    <a:pt x="0" y="90303"/>
+                  </a:moveTo>
+                  <a:lnTo>
+                    <a:pt x="90303" y="90303"/>
+                  </a:lnTo>
+                  <a:lnTo>
+                    <a:pt x="90303" y="0"/>
+                  </a:lnTo>
+                  <a:lnTo>
+                    <a:pt x="0" y="0"/>
+                  </a:lnTo>
+                  <a:close/>
+                </a:path>
+              </a:pathLst>
+            </a:custGeom>
+            <a:solidFill>
+              <a:srgbClr val="007B82">
+                <a:alpha val="100000"/>
+              </a:srgbClr>
+            </a:solidFill>
+          </p:spPr>
+          <p:txBody>
+            <a:bodyPr/>
+            <a:lstStyle/>
+            <a:p>
+              <a:endParaRPr/>
+            </a:p>
+          </p:txBody>
+        </p:sp>
+        <p:sp>
+          <p:nvSpPr>
+            <p:cNvPr id="28" name="pt28"/>
+            <p:cNvSpPr/>
+            <p:nvPr/>
+          </p:nvSpPr>
+          <p:spPr>
+            <a:xfrm>
+              <a:off x="5118909" y="2970574"/>
               <a:ext cx="90303" cy="90303"/>
             </a:xfrm>
             <a:prstGeom prst="ellipse">
@@ -4139,18 +4342,20 @@
           <p:txBody>
             <a:bodyPr/>
             <a:lstStyle/>
-            <a:p/>
-          </p:txBody>
-        </p:sp>
-        <p:sp>
-          <p:nvSpPr>
-            <p:cNvPr id="28" name="pt28"/>
+            <a:p>
+              <a:endParaRPr/>
+            </a:p>
+          </p:txBody>
+        </p:sp>
+        <p:sp>
+          <p:nvSpPr>
+            <p:cNvPr id="29" name="pt29"/>
             <p:cNvSpPr/>
             <p:nvPr/>
           </p:nvSpPr>
           <p:spPr>
             <a:xfrm>
-              <a:off x="6821222" y="1646511"/>
+              <a:off x="6887493" y="1646511"/>
               <a:ext cx="90303" cy="90303"/>
             </a:xfrm>
             <a:prstGeom prst="ellipse">
@@ -4174,22 +4379,28 @@
           <p:txBody>
             <a:bodyPr/>
             <a:lstStyle/>
-            <a:p/>
-          </p:txBody>
-        </p:sp>
-        <p:sp>
-          <p:nvSpPr>
-            <p:cNvPr id="29" name="pg29"/>
+            <a:p>
+              <a:endParaRPr/>
+            </a:p>
+          </p:txBody>
+        </p:sp>
+        <p:sp>
+          <p:nvSpPr>
+            <p:cNvPr id="30" name="pg30"/>
             <p:cNvSpPr/>
             <p:nvPr/>
           </p:nvSpPr>
           <p:spPr>
             <a:xfrm>
-              <a:off x="7099638" y="1621446"/>
+              <a:off x="7124490" y="1621446"/>
               <a:ext cx="121618" cy="105324"/>
             </a:xfrm>
             <a:custGeom>
               <a:avLst/>
+              <a:gdLst/>
+              <a:ahLst/>
+              <a:cxnLst/>
+              <a:rect l="0" t="0" r="0" b="0"/>
               <a:pathLst>
                 <a:path w="121618" h="105324">
                   <a:moveTo>
@@ -4214,22 +4425,28 @@
           <p:txBody>
             <a:bodyPr/>
             <a:lstStyle/>
-            <a:p/>
-          </p:txBody>
-        </p:sp>
-        <p:sp>
-          <p:nvSpPr>
-            <p:cNvPr id="30" name="pg30"/>
+            <a:p>
+              <a:endParaRPr/>
+            </a:p>
+          </p:txBody>
+        </p:sp>
+        <p:sp>
+          <p:nvSpPr>
+            <p:cNvPr id="31" name="pg31"/>
             <p:cNvSpPr/>
             <p:nvPr/>
           </p:nvSpPr>
           <p:spPr>
             <a:xfrm>
-              <a:off x="5041124" y="2745715"/>
+              <a:off x="5355907" y="2745715"/>
               <a:ext cx="121618" cy="105324"/>
             </a:xfrm>
             <a:custGeom>
               <a:avLst/>
+              <a:gdLst/>
+              <a:ahLst/>
+              <a:cxnLst/>
+              <a:rect l="0" t="0" r="0" b="0"/>
               <a:pathLst>
                 <a:path w="121618" h="105324">
                   <a:moveTo>
@@ -4254,18 +4471,20 @@
           <p:txBody>
             <a:bodyPr/>
             <a:lstStyle/>
-            <a:p/>
-          </p:txBody>
-        </p:sp>
-        <p:sp>
-          <p:nvSpPr>
-            <p:cNvPr id="31" name="pt31"/>
+            <a:p>
+              <a:endParaRPr/>
+            </a:p>
+          </p:txBody>
+        </p:sp>
+        <p:sp>
+          <p:nvSpPr>
+            <p:cNvPr id="32" name="pt32"/>
             <p:cNvSpPr/>
             <p:nvPr/>
           </p:nvSpPr>
           <p:spPr>
             <a:xfrm>
-              <a:off x="4468634" y="3041687"/>
+              <a:off x="4866255" y="3041687"/>
               <a:ext cx="90303" cy="90303"/>
             </a:xfrm>
             <a:prstGeom prst="ellipse">
@@ -4289,18 +4508,20 @@
           <p:txBody>
             <a:bodyPr/>
             <a:lstStyle/>
-            <a:p/>
-          </p:txBody>
-        </p:sp>
-        <p:sp>
-          <p:nvSpPr>
-            <p:cNvPr id="32" name="pt32"/>
+            <a:p>
+              <a:endParaRPr/>
+            </a:p>
+          </p:txBody>
+        </p:sp>
+        <p:sp>
+          <p:nvSpPr>
+            <p:cNvPr id="33" name="pt33"/>
             <p:cNvSpPr/>
             <p:nvPr/>
           </p:nvSpPr>
           <p:spPr>
             <a:xfrm>
-              <a:off x="5939002" y="1988532"/>
+              <a:off x="6129528" y="1988532"/>
               <a:ext cx="90303" cy="90303"/>
             </a:xfrm>
             <a:prstGeom prst="ellipse">
@@ -4324,22 +4545,28 @@
           <p:txBody>
             <a:bodyPr/>
             <a:lstStyle/>
-            <a:p/>
-          </p:txBody>
-        </p:sp>
-        <p:sp>
-          <p:nvSpPr>
-            <p:cNvPr id="33" name="pg33"/>
+            <a:p>
+              <a:endParaRPr/>
+            </a:p>
+          </p:txBody>
+        </p:sp>
+        <p:sp>
+          <p:nvSpPr>
+            <p:cNvPr id="34" name="pg34"/>
             <p:cNvSpPr/>
             <p:nvPr/>
           </p:nvSpPr>
           <p:spPr>
             <a:xfrm>
-              <a:off x="6217418" y="1963468"/>
+              <a:off x="6366526" y="1963468"/>
               <a:ext cx="121618" cy="105324"/>
             </a:xfrm>
             <a:custGeom>
               <a:avLst/>
+              <a:gdLst/>
+              <a:ahLst/>
+              <a:cxnLst/>
+              <a:rect l="0" t="0" r="0" b="0"/>
               <a:pathLst>
                 <a:path w="121618" h="105324">
                   <a:moveTo>
@@ -4364,18 +4591,20 @@
           <p:txBody>
             <a:bodyPr/>
             <a:lstStyle/>
-            <a:p/>
-          </p:txBody>
-        </p:sp>
-        <p:sp>
-          <p:nvSpPr>
-            <p:cNvPr id="34" name="pt34"/>
+            <a:p>
+              <a:endParaRPr/>
+            </a:p>
+          </p:txBody>
+        </p:sp>
+        <p:sp>
+          <p:nvSpPr>
+            <p:cNvPr id="35" name="pt35"/>
             <p:cNvSpPr/>
             <p:nvPr/>
           </p:nvSpPr>
           <p:spPr>
             <a:xfrm>
-              <a:off x="5350855" y="2547280"/>
+              <a:off x="5624219" y="2547280"/>
               <a:ext cx="90303" cy="90303"/>
             </a:xfrm>
             <a:prstGeom prst="ellipse">
@@ -4399,22 +4628,28 @@
           <p:txBody>
             <a:bodyPr/>
             <a:lstStyle/>
-            <a:p/>
-          </p:txBody>
-        </p:sp>
-        <p:sp>
-          <p:nvSpPr>
-            <p:cNvPr id="35" name="pg35"/>
+            <a:p>
+              <a:endParaRPr/>
+            </a:p>
+          </p:txBody>
+        </p:sp>
+        <p:sp>
+          <p:nvSpPr>
+            <p:cNvPr id="36" name="pg36"/>
             <p:cNvSpPr/>
             <p:nvPr/>
           </p:nvSpPr>
           <p:spPr>
             <a:xfrm>
-              <a:off x="6511491" y="1773832"/>
+              <a:off x="6619180" y="1773832"/>
               <a:ext cx="121618" cy="105324"/>
             </a:xfrm>
             <a:custGeom>
               <a:avLst/>
+              <a:gdLst/>
+              <a:ahLst/>
+              <a:cxnLst/>
+              <a:rect l="0" t="0" r="0" b="0"/>
               <a:pathLst>
                 <a:path w="121618" h="105324">
                   <a:moveTo>
@@ -4439,22 +4674,28 @@
           <p:txBody>
             <a:bodyPr/>
             <a:lstStyle/>
-            <a:p/>
-          </p:txBody>
-        </p:sp>
-        <p:sp>
-          <p:nvSpPr>
-            <p:cNvPr id="36" name="pg36"/>
+            <a:p>
+              <a:endParaRPr/>
+            </a:p>
+          </p:txBody>
+        </p:sp>
+        <p:sp>
+          <p:nvSpPr>
+            <p:cNvPr id="37" name="pg37"/>
             <p:cNvSpPr/>
             <p:nvPr/>
           </p:nvSpPr>
           <p:spPr>
             <a:xfrm>
-              <a:off x="5629271" y="2268239"/>
+              <a:off x="5861216" y="2268239"/>
               <a:ext cx="121618" cy="105324"/>
             </a:xfrm>
             <a:custGeom>
               <a:avLst/>
+              <a:gdLst/>
+              <a:ahLst/>
+              <a:cxnLst/>
+              <a:rect l="0" t="0" r="0" b="0"/>
               <a:pathLst>
                 <a:path w="121618" h="105324">
                   <a:moveTo>
@@ -4479,18 +4720,20 @@
           <p:txBody>
             <a:bodyPr/>
             <a:lstStyle/>
-            <a:p/>
-          </p:txBody>
-        </p:sp>
-        <p:sp>
-          <p:nvSpPr>
-            <p:cNvPr id="37" name="pt37"/>
+            <a:p>
+              <a:endParaRPr/>
+            </a:p>
+          </p:txBody>
+        </p:sp>
+        <p:sp>
+          <p:nvSpPr>
+            <p:cNvPr id="38" name="pt38"/>
             <p:cNvSpPr/>
             <p:nvPr/>
           </p:nvSpPr>
           <p:spPr>
             <a:xfrm>
-              <a:off x="4174561" y="3976320"/>
+              <a:off x="4108290" y="3976320"/>
               <a:ext cx="90303" cy="90303"/>
             </a:xfrm>
             <a:prstGeom prst="ellipse">
@@ -4514,12 +4757,109 @@
           <p:txBody>
             <a:bodyPr/>
             <a:lstStyle/>
-            <a:p/>
-          </p:txBody>
-        </p:sp>
-        <p:sp>
-          <p:nvSpPr>
-            <p:cNvPr id="38" name="pl38"/>
+            <a:p>
+              <a:endParaRPr/>
+            </a:p>
+          </p:txBody>
+        </p:sp>
+        <p:sp>
+          <p:nvSpPr>
+            <p:cNvPr id="39" name="pg39"/>
+            <p:cNvSpPr/>
+            <p:nvPr/>
+          </p:nvSpPr>
+          <p:spPr>
+            <a:xfrm>
+              <a:off x="4360945" y="3945843"/>
+              <a:ext cx="90303" cy="90303"/>
+            </a:xfrm>
+            <a:custGeom>
+              <a:avLst/>
+              <a:gdLst/>
+              <a:ahLst/>
+              <a:cxnLst/>
+              <a:rect l="0" t="0" r="0" b="0"/>
+              <a:pathLst>
+                <a:path w="90303" h="90303">
+                  <a:moveTo>
+                    <a:pt x="0" y="90303"/>
+                  </a:moveTo>
+                  <a:lnTo>
+                    <a:pt x="90303" y="90303"/>
+                  </a:lnTo>
+                  <a:lnTo>
+                    <a:pt x="90303" y="0"/>
+                  </a:lnTo>
+                  <a:lnTo>
+                    <a:pt x="0" y="0"/>
+                  </a:lnTo>
+                  <a:close/>
+                </a:path>
+              </a:pathLst>
+            </a:custGeom>
+            <a:solidFill>
+              <a:srgbClr val="007B82">
+                <a:alpha val="100000"/>
+              </a:srgbClr>
+            </a:solidFill>
+          </p:spPr>
+          <p:txBody>
+            <a:bodyPr/>
+            <a:lstStyle/>
+            <a:p>
+              <a:endParaRPr/>
+            </a:p>
+          </p:txBody>
+        </p:sp>
+        <p:sp>
+          <p:nvSpPr>
+            <p:cNvPr id="40" name="pg40"/>
+            <p:cNvSpPr/>
+            <p:nvPr/>
+          </p:nvSpPr>
+          <p:spPr>
+            <a:xfrm>
+              <a:off x="4597942" y="3368803"/>
+              <a:ext cx="121618" cy="105324"/>
+            </a:xfrm>
+            <a:custGeom>
+              <a:avLst/>
+              <a:gdLst/>
+              <a:ahLst/>
+              <a:cxnLst/>
+              <a:rect l="0" t="0" r="0" b="0"/>
+              <a:pathLst>
+                <a:path w="121618" h="105324">
+                  <a:moveTo>
+                    <a:pt x="60809" y="0"/>
+                  </a:moveTo>
+                  <a:lnTo>
+                    <a:pt x="121618" y="105324"/>
+                  </a:lnTo>
+                  <a:lnTo>
+                    <a:pt x="0" y="105324"/>
+                  </a:lnTo>
+                  <a:close/>
+                </a:path>
+              </a:pathLst>
+            </a:custGeom>
+            <a:solidFill>
+              <a:srgbClr val="F8766D">
+                <a:alpha val="100000"/>
+              </a:srgbClr>
+            </a:solidFill>
+          </p:spPr>
+          <p:txBody>
+            <a:bodyPr/>
+            <a:lstStyle/>
+            <a:p>
+              <a:endParaRPr/>
+            </a:p>
+          </p:txBody>
+        </p:sp>
+        <p:sp>
+          <p:nvSpPr>
+            <p:cNvPr id="41" name="pl41"/>
             <p:cNvSpPr/>
             <p:nvPr/>
           </p:nvSpPr>
@@ -4530,8 +4870,12 @@
             </a:xfrm>
             <a:custGeom>
               <a:avLst/>
+              <a:gdLst/>
+              <a:ahLst/>
+              <a:cxnLst/>
+              <a:rect l="0" t="0" r="0" b="0"/>
               <a:pathLst>
-                <a:path w="3587697" h="0">
+                <a:path w="3587697">
                   <a:moveTo>
                     <a:pt x="0" y="0"/>
                   </a:moveTo>
@@ -4557,12 +4901,14 @@
           <p:txBody>
             <a:bodyPr/>
             <a:lstStyle/>
-            <a:p/>
-          </p:txBody>
-        </p:sp>
-        <p:sp>
-          <p:nvSpPr>
-            <p:cNvPr id="39" name="rc39"/>
+            <a:p>
+              <a:endParaRPr/>
+            </a:p>
+          </p:txBody>
+        </p:sp>
+        <p:sp>
+          <p:nvSpPr>
+            <p:cNvPr id="42" name="rc42"/>
             <p:cNvSpPr/>
             <p:nvPr/>
           </p:nvSpPr>
@@ -4587,12 +4933,14 @@
           <p:txBody>
             <a:bodyPr/>
             <a:lstStyle/>
-            <a:p/>
-          </p:txBody>
-        </p:sp>
-        <p:sp>
-          <p:nvSpPr>
-            <p:cNvPr id="40" name="tx40"/>
+            <a:p>
+              <a:endParaRPr/>
+            </a:p>
+          </p:txBody>
+        </p:sp>
+        <p:sp>
+          <p:nvSpPr>
+            <p:cNvPr id="43" name="tx43"/>
             <p:cNvSpPr/>
             <p:nvPr/>
           </p:nvSpPr>
@@ -4607,10 +4955,10 @@
             <a:noFill/>
           </p:spPr>
           <p:txBody>
-            <a:bodyPr lIns="0" rIns="0" tIns="0" bIns="0" anchorCtr="1" anchor="ctr" wrap="none"/>
-            <a:lstStyle/>
-            <a:p>
-              <a:pPr algn="l" marL="0" marR="0" indent="0">
+            <a:bodyPr wrap="none" lIns="0" tIns="0" rIns="0" bIns="0" anchor="ctr" anchorCtr="1"/>
+            <a:lstStyle/>
+            <a:p>
+              <a:pPr marL="0" marR="0" indent="0" algn="l">
                 <a:lnSpc>
                   <a:spcPts val="880"/>
                 </a:lnSpc>
@@ -4638,7 +4986,7 @@
         </p:sp>
         <p:sp>
           <p:nvSpPr>
-            <p:cNvPr id="41" name="tx41"/>
+            <p:cNvPr id="44" name="tx44"/>
             <p:cNvSpPr/>
             <p:nvPr/>
           </p:nvSpPr>
@@ -4653,10 +5001,10 @@
             <a:noFill/>
           </p:spPr>
           <p:txBody>
-            <a:bodyPr lIns="0" rIns="0" tIns="0" bIns="0" anchorCtr="1" anchor="ctr" wrap="none"/>
-            <a:lstStyle/>
-            <a:p>
-              <a:pPr algn="l" marL="0" marR="0" indent="0">
+            <a:bodyPr wrap="none" lIns="0" tIns="0" rIns="0" bIns="0" anchor="ctr" anchorCtr="1"/>
+            <a:lstStyle/>
+            <a:p>
+              <a:pPr marL="0" marR="0" indent="0" algn="l">
                 <a:lnSpc>
                   <a:spcPts val="880"/>
                 </a:lnSpc>
@@ -4684,7 +5032,7 @@
         </p:sp>
         <p:sp>
           <p:nvSpPr>
-            <p:cNvPr id="42" name="tx42"/>
+            <p:cNvPr id="45" name="tx45"/>
             <p:cNvSpPr/>
             <p:nvPr/>
           </p:nvSpPr>
@@ -4699,10 +5047,10 @@
             <a:noFill/>
           </p:spPr>
           <p:txBody>
-            <a:bodyPr lIns="0" rIns="0" tIns="0" bIns="0" anchorCtr="1" anchor="ctr" wrap="none"/>
-            <a:lstStyle/>
-            <a:p>
-              <a:pPr algn="l" marL="0" marR="0" indent="0">
+            <a:bodyPr wrap="none" lIns="0" tIns="0" rIns="0" bIns="0" anchor="ctr" anchorCtr="1"/>
+            <a:lstStyle/>
+            <a:p>
+              <a:pPr marL="0" marR="0" indent="0" algn="l">
                 <a:lnSpc>
                   <a:spcPts val="880"/>
                 </a:lnSpc>
@@ -4730,7 +5078,7 @@
         </p:sp>
         <p:sp>
           <p:nvSpPr>
-            <p:cNvPr id="43" name="pl43"/>
+            <p:cNvPr id="46" name="pl46"/>
             <p:cNvSpPr/>
             <p:nvPr/>
           </p:nvSpPr>
@@ -4741,8 +5089,12 @@
             </a:xfrm>
             <a:custGeom>
               <a:avLst/>
+              <a:gdLst/>
+              <a:ahLst/>
+              <a:cxnLst/>
+              <a:rect l="0" t="0" r="0" b="0"/>
               <a:pathLst>
-                <a:path w="34794" h="0">
+                <a:path w="34794">
                   <a:moveTo>
                     <a:pt x="0" y="0"/>
                   </a:moveTo>
@@ -4765,12 +5117,14 @@
           <p:txBody>
             <a:bodyPr/>
             <a:lstStyle/>
-            <a:p/>
-          </p:txBody>
-        </p:sp>
-        <p:sp>
-          <p:nvSpPr>
-            <p:cNvPr id="44" name="pl44"/>
+            <a:p>
+              <a:endParaRPr/>
+            </a:p>
+          </p:txBody>
+        </p:sp>
+        <p:sp>
+          <p:nvSpPr>
+            <p:cNvPr id="47" name="pl47"/>
             <p:cNvSpPr/>
             <p:nvPr/>
           </p:nvSpPr>
@@ -4781,8 +5135,12 @@
             </a:xfrm>
             <a:custGeom>
               <a:avLst/>
+              <a:gdLst/>
+              <a:ahLst/>
+              <a:cxnLst/>
+              <a:rect l="0" t="0" r="0" b="0"/>
               <a:pathLst>
-                <a:path w="34794" h="0">
+                <a:path w="34794">
                   <a:moveTo>
                     <a:pt x="0" y="0"/>
                   </a:moveTo>
@@ -4805,12 +5163,14 @@
           <p:txBody>
             <a:bodyPr/>
             <a:lstStyle/>
-            <a:p/>
-          </p:txBody>
-        </p:sp>
-        <p:sp>
-          <p:nvSpPr>
-            <p:cNvPr id="45" name="pl45"/>
+            <a:p>
+              <a:endParaRPr/>
+            </a:p>
+          </p:txBody>
+        </p:sp>
+        <p:sp>
+          <p:nvSpPr>
+            <p:cNvPr id="48" name="pl48"/>
             <p:cNvSpPr/>
             <p:nvPr/>
           </p:nvSpPr>
@@ -4821,8 +5181,12 @@
             </a:xfrm>
             <a:custGeom>
               <a:avLst/>
+              <a:gdLst/>
+              <a:ahLst/>
+              <a:cxnLst/>
+              <a:rect l="0" t="0" r="0" b="0"/>
               <a:pathLst>
-                <a:path w="34794" h="0">
+                <a:path w="34794">
                   <a:moveTo>
                     <a:pt x="0" y="0"/>
                   </a:moveTo>
@@ -4845,24 +5209,30 @@
           <p:txBody>
             <a:bodyPr/>
             <a:lstStyle/>
-            <a:p/>
-          </p:txBody>
-        </p:sp>
-        <p:sp>
-          <p:nvSpPr>
-            <p:cNvPr id="46" name="pl46"/>
+            <a:p>
+              <a:endParaRPr/>
+            </a:p>
+          </p:txBody>
+        </p:sp>
+        <p:sp>
+          <p:nvSpPr>
+            <p:cNvPr id="49" name="pl49"/>
             <p:cNvSpPr/>
             <p:nvPr/>
           </p:nvSpPr>
           <p:spPr>
             <a:xfrm>
-              <a:off x="3925639" y="4351302"/>
+              <a:off x="3900788" y="4351302"/>
               <a:ext cx="0" cy="34794"/>
             </a:xfrm>
             <a:custGeom>
               <a:avLst/>
+              <a:gdLst/>
+              <a:ahLst/>
+              <a:cxnLst/>
+              <a:rect l="0" t="0" r="0" b="0"/>
               <a:pathLst>
-                <a:path w="0" h="34794">
+                <a:path h="34794">
                   <a:moveTo>
                     <a:pt x="0" y="34794"/>
                   </a:moveTo>
@@ -4885,24 +5255,30 @@
           <p:txBody>
             <a:bodyPr/>
             <a:lstStyle/>
-            <a:p/>
-          </p:txBody>
-        </p:sp>
-        <p:sp>
-          <p:nvSpPr>
-            <p:cNvPr id="47" name="pl47"/>
+            <a:p>
+              <a:endParaRPr/>
+            </a:p>
+          </p:txBody>
+        </p:sp>
+        <p:sp>
+          <p:nvSpPr>
+            <p:cNvPr id="50" name="pl50"/>
             <p:cNvSpPr/>
             <p:nvPr/>
           </p:nvSpPr>
           <p:spPr>
             <a:xfrm>
-              <a:off x="4219712" y="4351302"/>
+              <a:off x="4153442" y="4351302"/>
               <a:ext cx="0" cy="34794"/>
             </a:xfrm>
             <a:custGeom>
               <a:avLst/>
+              <a:gdLst/>
+              <a:ahLst/>
+              <a:cxnLst/>
+              <a:rect l="0" t="0" r="0" b="0"/>
               <a:pathLst>
-                <a:path w="0" h="34794">
+                <a:path h="34794">
                   <a:moveTo>
                     <a:pt x="0" y="34794"/>
                   </a:moveTo>
@@ -4925,24 +5301,30 @@
           <p:txBody>
             <a:bodyPr/>
             <a:lstStyle/>
-            <a:p/>
-          </p:txBody>
-        </p:sp>
-        <p:sp>
-          <p:nvSpPr>
-            <p:cNvPr id="48" name="pl48"/>
+            <a:p>
+              <a:endParaRPr/>
+            </a:p>
+          </p:txBody>
+        </p:sp>
+        <p:sp>
+          <p:nvSpPr>
+            <p:cNvPr id="51" name="pl51"/>
             <p:cNvSpPr/>
             <p:nvPr/>
           </p:nvSpPr>
           <p:spPr>
             <a:xfrm>
-              <a:off x="4513786" y="4351302"/>
+              <a:off x="4406097" y="4351302"/>
               <a:ext cx="0" cy="34794"/>
             </a:xfrm>
             <a:custGeom>
               <a:avLst/>
+              <a:gdLst/>
+              <a:ahLst/>
+              <a:cxnLst/>
+              <a:rect l="0" t="0" r="0" b="0"/>
               <a:pathLst>
-                <a:path w="0" h="34794">
+                <a:path h="34794">
                   <a:moveTo>
                     <a:pt x="0" y="34794"/>
                   </a:moveTo>
@@ -4965,24 +5347,30 @@
           <p:txBody>
             <a:bodyPr/>
             <a:lstStyle/>
-            <a:p/>
-          </p:txBody>
-        </p:sp>
-        <p:sp>
-          <p:nvSpPr>
-            <p:cNvPr id="49" name="pl49"/>
+            <a:p>
+              <a:endParaRPr/>
+            </a:p>
+          </p:txBody>
+        </p:sp>
+        <p:sp>
+          <p:nvSpPr>
+            <p:cNvPr id="52" name="pl52"/>
             <p:cNvSpPr/>
             <p:nvPr/>
           </p:nvSpPr>
           <p:spPr>
             <a:xfrm>
-              <a:off x="4807860" y="4351302"/>
+              <a:off x="4658752" y="4351302"/>
               <a:ext cx="0" cy="34794"/>
             </a:xfrm>
             <a:custGeom>
               <a:avLst/>
+              <a:gdLst/>
+              <a:ahLst/>
+              <a:cxnLst/>
+              <a:rect l="0" t="0" r="0" b="0"/>
               <a:pathLst>
-                <a:path w="0" h="34794">
+                <a:path h="34794">
                   <a:moveTo>
                     <a:pt x="0" y="34794"/>
                   </a:moveTo>
@@ -5005,24 +5393,30 @@
           <p:txBody>
             <a:bodyPr/>
             <a:lstStyle/>
-            <a:p/>
-          </p:txBody>
-        </p:sp>
-        <p:sp>
-          <p:nvSpPr>
-            <p:cNvPr id="50" name="pl50"/>
+            <a:p>
+              <a:endParaRPr/>
+            </a:p>
+          </p:txBody>
+        </p:sp>
+        <p:sp>
+          <p:nvSpPr>
+            <p:cNvPr id="53" name="pl53"/>
             <p:cNvSpPr/>
             <p:nvPr/>
           </p:nvSpPr>
           <p:spPr>
             <a:xfrm>
-              <a:off x="5101933" y="4351302"/>
+              <a:off x="4911407" y="4351302"/>
               <a:ext cx="0" cy="34794"/>
             </a:xfrm>
             <a:custGeom>
               <a:avLst/>
+              <a:gdLst/>
+              <a:ahLst/>
+              <a:cxnLst/>
+              <a:rect l="0" t="0" r="0" b="0"/>
               <a:pathLst>
-                <a:path w="0" h="34794">
+                <a:path h="34794">
                   <a:moveTo>
                     <a:pt x="0" y="34794"/>
                   </a:moveTo>
@@ -5045,24 +5439,30 @@
           <p:txBody>
             <a:bodyPr/>
             <a:lstStyle/>
-            <a:p/>
-          </p:txBody>
-        </p:sp>
-        <p:sp>
-          <p:nvSpPr>
-            <p:cNvPr id="51" name="pl51"/>
+            <a:p>
+              <a:endParaRPr/>
+            </a:p>
+          </p:txBody>
+        </p:sp>
+        <p:sp>
+          <p:nvSpPr>
+            <p:cNvPr id="54" name="pl54"/>
             <p:cNvSpPr/>
             <p:nvPr/>
           </p:nvSpPr>
           <p:spPr>
             <a:xfrm>
-              <a:off x="5396007" y="4351302"/>
+              <a:off x="5164061" y="4351302"/>
               <a:ext cx="0" cy="34794"/>
             </a:xfrm>
             <a:custGeom>
               <a:avLst/>
+              <a:gdLst/>
+              <a:ahLst/>
+              <a:cxnLst/>
+              <a:rect l="0" t="0" r="0" b="0"/>
               <a:pathLst>
-                <a:path w="0" h="34794">
+                <a:path h="34794">
                   <a:moveTo>
                     <a:pt x="0" y="34794"/>
                   </a:moveTo>
@@ -5085,24 +5485,30 @@
           <p:txBody>
             <a:bodyPr/>
             <a:lstStyle/>
-            <a:p/>
-          </p:txBody>
-        </p:sp>
-        <p:sp>
-          <p:nvSpPr>
-            <p:cNvPr id="52" name="pl52"/>
+            <a:p>
+              <a:endParaRPr/>
+            </a:p>
+          </p:txBody>
+        </p:sp>
+        <p:sp>
+          <p:nvSpPr>
+            <p:cNvPr id="55" name="pl55"/>
             <p:cNvSpPr/>
             <p:nvPr/>
           </p:nvSpPr>
           <p:spPr>
             <a:xfrm>
-              <a:off x="5690080" y="4351302"/>
+              <a:off x="5416716" y="4351302"/>
               <a:ext cx="0" cy="34794"/>
             </a:xfrm>
             <a:custGeom>
               <a:avLst/>
+              <a:gdLst/>
+              <a:ahLst/>
+              <a:cxnLst/>
+              <a:rect l="0" t="0" r="0" b="0"/>
               <a:pathLst>
-                <a:path w="0" h="34794">
+                <a:path h="34794">
                   <a:moveTo>
                     <a:pt x="0" y="34794"/>
                   </a:moveTo>
@@ -5125,24 +5531,30 @@
           <p:txBody>
             <a:bodyPr/>
             <a:lstStyle/>
-            <a:p/>
-          </p:txBody>
-        </p:sp>
-        <p:sp>
-          <p:nvSpPr>
-            <p:cNvPr id="53" name="pl53"/>
+            <a:p>
+              <a:endParaRPr/>
+            </a:p>
+          </p:txBody>
+        </p:sp>
+        <p:sp>
+          <p:nvSpPr>
+            <p:cNvPr id="56" name="pl56"/>
             <p:cNvSpPr/>
             <p:nvPr/>
           </p:nvSpPr>
           <p:spPr>
             <a:xfrm>
-              <a:off x="5984154" y="4351302"/>
+              <a:off x="5669371" y="4351302"/>
               <a:ext cx="0" cy="34794"/>
             </a:xfrm>
             <a:custGeom>
               <a:avLst/>
+              <a:gdLst/>
+              <a:ahLst/>
+              <a:cxnLst/>
+              <a:rect l="0" t="0" r="0" b="0"/>
               <a:pathLst>
-                <a:path w="0" h="34794">
+                <a:path h="34794">
                   <a:moveTo>
                     <a:pt x="0" y="34794"/>
                   </a:moveTo>
@@ -5165,24 +5577,30 @@
           <p:txBody>
             <a:bodyPr/>
             <a:lstStyle/>
-            <a:p/>
-          </p:txBody>
-        </p:sp>
-        <p:sp>
-          <p:nvSpPr>
-            <p:cNvPr id="54" name="pl54"/>
+            <a:p>
+              <a:endParaRPr/>
+            </a:p>
+          </p:txBody>
+        </p:sp>
+        <p:sp>
+          <p:nvSpPr>
+            <p:cNvPr id="57" name="pl57"/>
             <p:cNvSpPr/>
             <p:nvPr/>
           </p:nvSpPr>
           <p:spPr>
             <a:xfrm>
-              <a:off x="6278227" y="4351302"/>
+              <a:off x="5922025" y="4351302"/>
               <a:ext cx="0" cy="34794"/>
             </a:xfrm>
             <a:custGeom>
               <a:avLst/>
+              <a:gdLst/>
+              <a:ahLst/>
+              <a:cxnLst/>
+              <a:rect l="0" t="0" r="0" b="0"/>
               <a:pathLst>
-                <a:path w="0" h="34794">
+                <a:path h="34794">
                   <a:moveTo>
                     <a:pt x="0" y="34794"/>
                   </a:moveTo>
@@ -5205,24 +5623,30 @@
           <p:txBody>
             <a:bodyPr/>
             <a:lstStyle/>
-            <a:p/>
-          </p:txBody>
-        </p:sp>
-        <p:sp>
-          <p:nvSpPr>
-            <p:cNvPr id="55" name="pl55"/>
+            <a:p>
+              <a:endParaRPr/>
+            </a:p>
+          </p:txBody>
+        </p:sp>
+        <p:sp>
+          <p:nvSpPr>
+            <p:cNvPr id="58" name="pl58"/>
             <p:cNvSpPr/>
             <p:nvPr/>
           </p:nvSpPr>
           <p:spPr>
             <a:xfrm>
-              <a:off x="6572301" y="4351302"/>
+              <a:off x="6174680" y="4351302"/>
               <a:ext cx="0" cy="34794"/>
             </a:xfrm>
             <a:custGeom>
               <a:avLst/>
+              <a:gdLst/>
+              <a:ahLst/>
+              <a:cxnLst/>
+              <a:rect l="0" t="0" r="0" b="0"/>
               <a:pathLst>
-                <a:path w="0" h="34794">
+                <a:path h="34794">
                   <a:moveTo>
                     <a:pt x="0" y="34794"/>
                   </a:moveTo>
@@ -5245,24 +5669,30 @@
           <p:txBody>
             <a:bodyPr/>
             <a:lstStyle/>
-            <a:p/>
-          </p:txBody>
-        </p:sp>
-        <p:sp>
-          <p:nvSpPr>
-            <p:cNvPr id="56" name="pl56"/>
+            <a:p>
+              <a:endParaRPr/>
+            </a:p>
+          </p:txBody>
+        </p:sp>
+        <p:sp>
+          <p:nvSpPr>
+            <p:cNvPr id="59" name="pl59"/>
             <p:cNvSpPr/>
             <p:nvPr/>
           </p:nvSpPr>
           <p:spPr>
             <a:xfrm>
-              <a:off x="6866374" y="4351302"/>
+              <a:off x="6427335" y="4351302"/>
               <a:ext cx="0" cy="34794"/>
             </a:xfrm>
             <a:custGeom>
               <a:avLst/>
+              <a:gdLst/>
+              <a:ahLst/>
+              <a:cxnLst/>
+              <a:rect l="0" t="0" r="0" b="0"/>
               <a:pathLst>
-                <a:path w="0" h="34794">
+                <a:path h="34794">
                   <a:moveTo>
                     <a:pt x="0" y="34794"/>
                   </a:moveTo>
@@ -5285,24 +5715,30 @@
           <p:txBody>
             <a:bodyPr/>
             <a:lstStyle/>
-            <a:p/>
-          </p:txBody>
-        </p:sp>
-        <p:sp>
-          <p:nvSpPr>
-            <p:cNvPr id="57" name="pl57"/>
+            <a:p>
+              <a:endParaRPr/>
+            </a:p>
+          </p:txBody>
+        </p:sp>
+        <p:sp>
+          <p:nvSpPr>
+            <p:cNvPr id="60" name="pl60"/>
             <p:cNvSpPr/>
             <p:nvPr/>
           </p:nvSpPr>
           <p:spPr>
             <a:xfrm>
-              <a:off x="7160448" y="4351302"/>
+              <a:off x="6679990" y="4351302"/>
               <a:ext cx="0" cy="34794"/>
             </a:xfrm>
             <a:custGeom>
               <a:avLst/>
+              <a:gdLst/>
+              <a:ahLst/>
+              <a:cxnLst/>
+              <a:rect l="0" t="0" r="0" b="0"/>
               <a:pathLst>
-                <a:path w="0" h="34794">
+                <a:path h="34794">
                   <a:moveTo>
                     <a:pt x="0" y="34794"/>
                   </a:moveTo>
@@ -5325,18 +5761,112 @@
           <p:txBody>
             <a:bodyPr/>
             <a:lstStyle/>
-            <a:p/>
-          </p:txBody>
-        </p:sp>
-        <p:sp>
-          <p:nvSpPr>
-            <p:cNvPr id="58" name="tx58"/>
+            <a:p>
+              <a:endParaRPr/>
+            </a:p>
+          </p:txBody>
+        </p:sp>
+        <p:sp>
+          <p:nvSpPr>
+            <p:cNvPr id="61" name="pl61"/>
+            <p:cNvSpPr/>
+            <p:nvPr/>
+          </p:nvSpPr>
+          <p:spPr>
+            <a:xfrm>
+              <a:off x="6932644" y="4351302"/>
+              <a:ext cx="0" cy="34794"/>
+            </a:xfrm>
+            <a:custGeom>
+              <a:avLst/>
+              <a:gdLst/>
+              <a:ahLst/>
+              <a:cxnLst/>
+              <a:rect l="0" t="0" r="0" b="0"/>
+              <a:pathLst>
+                <a:path h="34794">
+                  <a:moveTo>
+                    <a:pt x="0" y="34794"/>
+                  </a:moveTo>
+                  <a:lnTo>
+                    <a:pt x="0" y="0"/>
+                  </a:lnTo>
+                </a:path>
+              </a:pathLst>
+            </a:custGeom>
+            <a:ln w="13550" cap="flat">
+              <a:solidFill>
+                <a:srgbClr val="333333">
+                  <a:alpha val="100000"/>
+                </a:srgbClr>
+              </a:solidFill>
+              <a:prstDash val="solid"/>
+              <a:round/>
+            </a:ln>
+          </p:spPr>
+          <p:txBody>
+            <a:bodyPr/>
+            <a:lstStyle/>
+            <a:p>
+              <a:endParaRPr/>
+            </a:p>
+          </p:txBody>
+        </p:sp>
+        <p:sp>
+          <p:nvSpPr>
+            <p:cNvPr id="62" name="pl62"/>
+            <p:cNvSpPr/>
+            <p:nvPr/>
+          </p:nvSpPr>
+          <p:spPr>
+            <a:xfrm>
+              <a:off x="7185299" y="4351302"/>
+              <a:ext cx="0" cy="34794"/>
+            </a:xfrm>
+            <a:custGeom>
+              <a:avLst/>
+              <a:gdLst/>
+              <a:ahLst/>
+              <a:cxnLst/>
+              <a:rect l="0" t="0" r="0" b="0"/>
+              <a:pathLst>
+                <a:path h="34794">
+                  <a:moveTo>
+                    <a:pt x="0" y="34794"/>
+                  </a:moveTo>
+                  <a:lnTo>
+                    <a:pt x="0" y="0"/>
+                  </a:lnTo>
+                </a:path>
+              </a:pathLst>
+            </a:custGeom>
+            <a:ln w="13550" cap="flat">
+              <a:solidFill>
+                <a:srgbClr val="333333">
+                  <a:alpha val="100000"/>
+                </a:srgbClr>
+              </a:solidFill>
+              <a:prstDash val="solid"/>
+              <a:round/>
+            </a:ln>
+          </p:spPr>
+          <p:txBody>
+            <a:bodyPr/>
+            <a:lstStyle/>
+            <a:p>
+              <a:endParaRPr/>
+            </a:p>
+          </p:txBody>
+        </p:sp>
+        <p:sp>
+          <p:nvSpPr>
+            <p:cNvPr id="63" name="tx63"/>
             <p:cNvSpPr/>
             <p:nvPr/>
           </p:nvSpPr>
           <p:spPr>
             <a:xfrm rot="-2700000">
-              <a:off x="3805477" y="4463705"/>
+              <a:off x="3780626" y="4463705"/>
               <a:ext cx="173915" cy="80000"/>
             </a:xfrm>
             <a:prstGeom prst="rect">
@@ -5345,10 +5875,10 @@
             <a:noFill/>
           </p:spPr>
           <p:txBody>
-            <a:bodyPr lIns="0" rIns="0" tIns="0" bIns="0" anchorCtr="1" anchor="ctr" wrap="none"/>
-            <a:lstStyle/>
-            <a:p>
-              <a:pPr algn="l" marL="0" marR="0" indent="0">
+            <a:bodyPr wrap="none" lIns="0" tIns="0" rIns="0" bIns="0" anchor="ctr" anchorCtr="1"/>
+            <a:lstStyle/>
+            <a:p>
+              <a:pPr marL="0" marR="0" indent="0" algn="l">
                 <a:lnSpc>
                   <a:spcPts val="880"/>
                 </a:lnSpc>
@@ -5376,13 +5906,13 @@
         </p:sp>
         <p:sp>
           <p:nvSpPr>
-            <p:cNvPr id="59" name="tx59"/>
+            <p:cNvPr id="64" name="tx64"/>
             <p:cNvSpPr/>
             <p:nvPr/>
           </p:nvSpPr>
           <p:spPr>
             <a:xfrm rot="-2700000">
-              <a:off x="3645877" y="4628048"/>
+              <a:off x="3579607" y="4628048"/>
               <a:ext cx="695662" cy="103574"/>
             </a:xfrm>
             <a:prstGeom prst="rect">
@@ -5391,10 +5921,10 @@
             <a:noFill/>
           </p:spPr>
           <p:txBody>
-            <a:bodyPr lIns="0" rIns="0" tIns="0" bIns="0" anchorCtr="1" anchor="ctr" wrap="none"/>
-            <a:lstStyle/>
-            <a:p>
-              <a:pPr algn="l" marL="0" marR="0" indent="0">
+            <a:bodyPr wrap="none" lIns="0" tIns="0" rIns="0" bIns="0" anchor="ctr" anchorCtr="1"/>
+            <a:lstStyle/>
+            <a:p>
+              <a:pPr marL="0" marR="0" indent="0" algn="l">
                 <a:lnSpc>
                   <a:spcPts val="880"/>
                 </a:lnSpc>
@@ -5422,14 +5952,14 @@
         </p:sp>
         <p:sp>
           <p:nvSpPr>
-            <p:cNvPr id="60" name="tx60"/>
+            <p:cNvPr id="65" name="tx65"/>
             <p:cNvSpPr/>
             <p:nvPr/>
           </p:nvSpPr>
           <p:spPr>
             <a:xfrm rot="-2700000">
-              <a:off x="3786194" y="4691736"/>
-              <a:ext cx="875798" cy="103574"/>
+              <a:off x="3994446" y="4584444"/>
+              <a:ext cx="515416" cy="80000"/>
             </a:xfrm>
             <a:prstGeom prst="rect">
               <a:avLst/>
@@ -5437,10 +5967,102 @@
             <a:noFill/>
           </p:spPr>
           <p:txBody>
-            <a:bodyPr lIns="0" rIns="0" tIns="0" bIns="0" anchorCtr="1" anchor="ctr" wrap="none"/>
-            <a:lstStyle/>
-            <a:p>
-              <a:pPr algn="l" marL="0" marR="0" indent="0">
+            <a:bodyPr wrap="none" lIns="0" tIns="0" rIns="0" bIns="0" anchor="ctr" anchorCtr="1"/>
+            <a:lstStyle/>
+            <a:p>
+              <a:pPr marL="0" marR="0" indent="0" algn="l">
+                <a:lnSpc>
+                  <a:spcPts val="880"/>
+                </a:lnSpc>
+                <a:spcBef>
+                  <a:spcPts val="0"/>
+                </a:spcBef>
+                <a:spcAft>
+                  <a:spcPts val="0"/>
+                </a:spcAft>
+              </a:pPr>
+              <a:r>
+                <a:rPr sz="880">
+                  <a:solidFill>
+                    <a:srgbClr val="4D4D4D">
+                      <a:alpha val="100000"/>
+                    </a:srgbClr>
+                  </a:solidFill>
+                  <a:latin typeface="Arial"/>
+                  <a:cs typeface="Arial"/>
+                </a:rPr>
+                <a:t>ADNI PET</a:t>
+              </a:r>
+            </a:p>
+          </p:txBody>
+        </p:sp>
+        <p:sp>
+          <p:nvSpPr>
+            <p:cNvPr id="66" name="tx66"/>
+            <p:cNvSpPr/>
+            <p:nvPr/>
+          </p:nvSpPr>
+          <p:spPr>
+            <a:xfrm rot="-2700000">
+              <a:off x="3787838" y="4751102"/>
+              <a:ext cx="1043711" cy="103574"/>
+            </a:xfrm>
+            <a:prstGeom prst="rect">
+              <a:avLst/>
+            </a:prstGeom>
+            <a:noFill/>
+          </p:spPr>
+          <p:txBody>
+            <a:bodyPr wrap="none" lIns="0" tIns="0" rIns="0" bIns="0" anchor="ctr" anchorCtr="1"/>
+            <a:lstStyle/>
+            <a:p>
+              <a:pPr marL="0" marR="0" indent="0" algn="l">
+                <a:lnSpc>
+                  <a:spcPts val="880"/>
+                </a:lnSpc>
+                <a:spcBef>
+                  <a:spcPts val="0"/>
+                </a:spcBef>
+                <a:spcAft>
+                  <a:spcPts val="0"/>
+                </a:spcAft>
+              </a:pPr>
+              <a:r>
+                <a:rPr sz="880">
+                  <a:solidFill>
+                    <a:srgbClr val="4D4D4D">
+                      <a:alpha val="100000"/>
+                    </a:srgbClr>
+                  </a:solidFill>
+                  <a:latin typeface="Arial"/>
+                  <a:cs typeface="Arial"/>
+                </a:rPr>
+                <a:t>ADNI pTau217/AB42</a:t>
+              </a:r>
+            </a:p>
+          </p:txBody>
+        </p:sp>
+        <p:sp>
+          <p:nvSpPr>
+            <p:cNvPr id="67" name="tx67"/>
+            <p:cNvSpPr/>
+            <p:nvPr/>
+          </p:nvSpPr>
+          <p:spPr>
+            <a:xfrm rot="-2700000">
+              <a:off x="4183815" y="4691736"/>
+              <a:ext cx="875798" cy="103574"/>
+            </a:xfrm>
+            <a:prstGeom prst="rect">
+              <a:avLst/>
+            </a:prstGeom>
+            <a:noFill/>
+          </p:spPr>
+          <p:txBody>
+            <a:bodyPr wrap="none" lIns="0" tIns="0" rIns="0" bIns="0" anchor="ctr" anchorCtr="1"/>
+            <a:lstStyle/>
+            <a:p>
+              <a:pPr marL="0" marR="0" indent="0" algn="l">
                 <a:lnSpc>
                   <a:spcPts val="880"/>
                 </a:lnSpc>
@@ -5468,13 +6090,13 @@
         </p:sp>
         <p:sp>
           <p:nvSpPr>
-            <p:cNvPr id="61" name="tx61"/>
+            <p:cNvPr id="68" name="tx68"/>
             <p:cNvSpPr/>
             <p:nvPr/>
           </p:nvSpPr>
           <p:spPr>
             <a:xfrm rot="-2700000">
-              <a:off x="4080268" y="4691736"/>
+              <a:off x="4436470" y="4691736"/>
               <a:ext cx="875798" cy="103574"/>
             </a:xfrm>
             <a:prstGeom prst="rect">
@@ -5483,10 +6105,10 @@
             <a:noFill/>
           </p:spPr>
           <p:txBody>
-            <a:bodyPr lIns="0" rIns="0" tIns="0" bIns="0" anchorCtr="1" anchor="ctr" wrap="none"/>
-            <a:lstStyle/>
-            <a:p>
-              <a:pPr algn="l" marL="0" marR="0" indent="0">
+            <a:bodyPr wrap="none" lIns="0" tIns="0" rIns="0" bIns="0" anchor="ctr" anchorCtr="1"/>
+            <a:lstStyle/>
+            <a:p>
+              <a:pPr marL="0" marR="0" indent="0" algn="l">
                 <a:lnSpc>
                   <a:spcPts val="880"/>
                 </a:lnSpc>
@@ -5514,13 +6136,13 @@
         </p:sp>
         <p:sp>
           <p:nvSpPr>
-            <p:cNvPr id="62" name="tx62"/>
+            <p:cNvPr id="69" name="tx69"/>
             <p:cNvSpPr/>
             <p:nvPr/>
           </p:nvSpPr>
           <p:spPr>
             <a:xfrm rot="-2700000">
-              <a:off x="4247042" y="4744466"/>
+              <a:off x="4561825" y="4744466"/>
               <a:ext cx="1024939" cy="103574"/>
             </a:xfrm>
             <a:prstGeom prst="rect">
@@ -5529,10 +6151,10 @@
             <a:noFill/>
           </p:spPr>
           <p:txBody>
-            <a:bodyPr lIns="0" rIns="0" tIns="0" bIns="0" anchorCtr="1" anchor="ctr" wrap="none"/>
-            <a:lstStyle/>
-            <a:p>
-              <a:pPr algn="l" marL="0" marR="0" indent="0">
+            <a:bodyPr wrap="none" lIns="0" tIns="0" rIns="0" bIns="0" anchor="ctr" anchorCtr="1"/>
+            <a:lstStyle/>
+            <a:p>
+              <a:pPr marL="0" marR="0" indent="0" algn="l">
                 <a:lnSpc>
                   <a:spcPts val="880"/>
                 </a:lnSpc>
@@ -5560,13 +6182,13 @@
         </p:sp>
         <p:sp>
           <p:nvSpPr>
-            <p:cNvPr id="63" name="tx63"/>
+            <p:cNvPr id="70" name="tx70"/>
             <p:cNvSpPr/>
             <p:nvPr/>
           </p:nvSpPr>
           <p:spPr>
             <a:xfrm rot="-2700000">
-              <a:off x="4466822" y="4775239"/>
+              <a:off x="4740187" y="4775239"/>
               <a:ext cx="1111979" cy="103574"/>
             </a:xfrm>
             <a:prstGeom prst="rect">
@@ -5575,10 +6197,10 @@
             <a:noFill/>
           </p:spPr>
           <p:txBody>
-            <a:bodyPr lIns="0" rIns="0" tIns="0" bIns="0" anchorCtr="1" anchor="ctr" wrap="none"/>
-            <a:lstStyle/>
-            <a:p>
-              <a:pPr algn="l" marL="0" marR="0" indent="0">
+            <a:bodyPr wrap="none" lIns="0" tIns="0" rIns="0" bIns="0" anchor="ctr" anchorCtr="1"/>
+            <a:lstStyle/>
+            <a:p>
+              <a:pPr marL="0" marR="0" indent="0" algn="l">
                 <a:lnSpc>
                   <a:spcPts val="880"/>
                 </a:lnSpc>
@@ -5606,13 +6228,13 @@
         </p:sp>
         <p:sp>
           <p:nvSpPr>
-            <p:cNvPr id="64" name="tx64"/>
+            <p:cNvPr id="71" name="tx71"/>
             <p:cNvSpPr/>
             <p:nvPr/>
           </p:nvSpPr>
           <p:spPr>
             <a:xfrm rot="-2700000">
-              <a:off x="4798019" y="4759862"/>
+              <a:off x="5029965" y="4759862"/>
               <a:ext cx="1068486" cy="103574"/>
             </a:xfrm>
             <a:prstGeom prst="rect">
@@ -5621,10 +6243,10 @@
             <a:noFill/>
           </p:spPr>
           <p:txBody>
-            <a:bodyPr lIns="0" rIns="0" tIns="0" bIns="0" anchorCtr="1" anchor="ctr" wrap="none"/>
-            <a:lstStyle/>
-            <a:p>
-              <a:pPr algn="l" marL="0" marR="0" indent="0">
+            <a:bodyPr wrap="none" lIns="0" tIns="0" rIns="0" bIns="0" anchor="ctr" anchorCtr="1"/>
+            <a:lstStyle/>
+            <a:p>
+              <a:pPr marL="0" marR="0" indent="0" algn="l">
                 <a:lnSpc>
                   <a:spcPts val="880"/>
                 </a:lnSpc>
@@ -5652,13 +6274,13 @@
         </p:sp>
         <p:sp>
           <p:nvSpPr>
-            <p:cNvPr id="65" name="tx65"/>
+            <p:cNvPr id="72" name="tx72"/>
             <p:cNvSpPr/>
             <p:nvPr/>
           </p:nvSpPr>
           <p:spPr>
             <a:xfrm rot="-2700000">
-              <a:off x="5187626" y="4720291"/>
+              <a:off x="5378152" y="4720291"/>
               <a:ext cx="956563" cy="103574"/>
             </a:xfrm>
             <a:prstGeom prst="rect">
@@ -5667,10 +6289,10 @@
             <a:noFill/>
           </p:spPr>
           <p:txBody>
-            <a:bodyPr lIns="0" rIns="0" tIns="0" bIns="0" anchorCtr="1" anchor="ctr" wrap="none"/>
-            <a:lstStyle/>
-            <a:p>
-              <a:pPr algn="l" marL="0" marR="0" indent="0">
+            <a:bodyPr wrap="none" lIns="0" tIns="0" rIns="0" bIns="0" anchor="ctr" anchorCtr="1"/>
+            <a:lstStyle/>
+            <a:p>
+              <a:pPr marL="0" marR="0" indent="0" algn="l">
                 <a:lnSpc>
                   <a:spcPts val="880"/>
                 </a:lnSpc>
@@ -5698,13 +6320,13 @@
         </p:sp>
         <p:sp>
           <p:nvSpPr>
-            <p:cNvPr id="66" name="tx66"/>
+            <p:cNvPr id="73" name="tx73"/>
             <p:cNvSpPr/>
             <p:nvPr/>
           </p:nvSpPr>
           <p:spPr>
             <a:xfrm rot="-2700000">
-              <a:off x="5354766" y="4773905"/>
+              <a:off x="5503874" y="4773905"/>
               <a:ext cx="1105703" cy="102537"/>
             </a:xfrm>
             <a:prstGeom prst="rect">
@@ -5713,10 +6335,10 @@
             <a:noFill/>
           </p:spPr>
           <p:txBody>
-            <a:bodyPr lIns="0" rIns="0" tIns="0" bIns="0" anchorCtr="1" anchor="ctr" wrap="none"/>
-            <a:lstStyle/>
-            <a:p>
-              <a:pPr algn="l" marL="0" marR="0" indent="0">
+            <a:bodyPr wrap="none" lIns="0" tIns="0" rIns="0" bIns="0" anchor="ctr" anchorCtr="1"/>
+            <a:lstStyle/>
+            <a:p>
+              <a:pPr marL="0" marR="0" indent="0" algn="l">
                 <a:lnSpc>
                   <a:spcPts val="880"/>
                 </a:lnSpc>
@@ -5744,13 +6366,13 @@
         </p:sp>
         <p:sp>
           <p:nvSpPr>
-            <p:cNvPr id="67" name="tx67"/>
+            <p:cNvPr id="74" name="tx74"/>
             <p:cNvSpPr/>
             <p:nvPr/>
           </p:nvSpPr>
           <p:spPr>
             <a:xfrm rot="-2700000">
-              <a:off x="5717410" y="4744466"/>
+              <a:off x="5825098" y="4744466"/>
               <a:ext cx="1024939" cy="103574"/>
             </a:xfrm>
             <a:prstGeom prst="rect">
@@ -5759,10 +6381,10 @@
             <a:noFill/>
           </p:spPr>
           <p:txBody>
-            <a:bodyPr lIns="0" rIns="0" tIns="0" bIns="0" anchorCtr="1" anchor="ctr" wrap="none"/>
-            <a:lstStyle/>
-            <a:p>
-              <a:pPr algn="l" marL="0" marR="0" indent="0">
+            <a:bodyPr wrap="none" lIns="0" tIns="0" rIns="0" bIns="0" anchor="ctr" anchorCtr="1"/>
+            <a:lstStyle/>
+            <a:p>
+              <a:pPr marL="0" marR="0" indent="0" algn="l">
                 <a:lnSpc>
                   <a:spcPts val="880"/>
                 </a:lnSpc>
@@ -5790,13 +6412,13 @@
         </p:sp>
         <p:sp>
           <p:nvSpPr>
-            <p:cNvPr id="68" name="tx68"/>
+            <p:cNvPr id="75" name="tx75"/>
             <p:cNvSpPr/>
             <p:nvPr/>
           </p:nvSpPr>
           <p:spPr>
             <a:xfrm rot="-2700000">
-              <a:off x="6069846" y="4720291"/>
+              <a:off x="6136116" y="4720291"/>
               <a:ext cx="956563" cy="103574"/>
             </a:xfrm>
             <a:prstGeom prst="rect">
@@ -5805,10 +6427,10 @@
             <a:noFill/>
           </p:spPr>
           <p:txBody>
-            <a:bodyPr lIns="0" rIns="0" tIns="0" bIns="0" anchorCtr="1" anchor="ctr" wrap="none"/>
-            <a:lstStyle/>
-            <a:p>
-              <a:pPr algn="l" marL="0" marR="0" indent="0">
+            <a:bodyPr wrap="none" lIns="0" tIns="0" rIns="0" bIns="0" anchor="ctr" anchorCtr="1"/>
+            <a:lstStyle/>
+            <a:p>
+              <a:pPr marL="0" marR="0" indent="0" algn="l">
                 <a:lnSpc>
                   <a:spcPts val="880"/>
                 </a:lnSpc>
@@ -5836,13 +6458,13 @@
         </p:sp>
         <p:sp>
           <p:nvSpPr>
-            <p:cNvPr id="69" name="tx69"/>
+            <p:cNvPr id="76" name="tx76"/>
             <p:cNvSpPr/>
             <p:nvPr/>
           </p:nvSpPr>
           <p:spPr>
             <a:xfrm rot="-2700000">
-              <a:off x="6236987" y="4773905"/>
+              <a:off x="6261838" y="4773905"/>
               <a:ext cx="1105703" cy="102537"/>
             </a:xfrm>
             <a:prstGeom prst="rect">
@@ -5851,10 +6473,10 @@
             <a:noFill/>
           </p:spPr>
           <p:txBody>
-            <a:bodyPr lIns="0" rIns="0" tIns="0" bIns="0" anchorCtr="1" anchor="ctr" wrap="none"/>
-            <a:lstStyle/>
-            <a:p>
-              <a:pPr algn="l" marL="0" marR="0" indent="0">
+            <a:bodyPr wrap="none" lIns="0" tIns="0" rIns="0" bIns="0" anchor="ctr" anchorCtr="1"/>
+            <a:lstStyle/>
+            <a:p>
+              <a:pPr marL="0" marR="0" indent="0" algn="l">
                 <a:lnSpc>
                   <a:spcPts val="880"/>
                 </a:lnSpc>
@@ -5882,7 +6504,7 @@
         </p:sp>
         <p:sp>
           <p:nvSpPr>
-            <p:cNvPr id="70" name="tx70"/>
+            <p:cNvPr id="77" name="tx77"/>
             <p:cNvSpPr/>
             <p:nvPr/>
           </p:nvSpPr>
@@ -5897,10 +6519,10 @@
             <a:noFill/>
           </p:spPr>
           <p:txBody>
-            <a:bodyPr lIns="0" rIns="0" tIns="0" bIns="0" anchorCtr="1" anchor="ctr" wrap="none"/>
-            <a:lstStyle/>
-            <a:p>
-              <a:pPr algn="l" marL="0" marR="0" indent="0">
+            <a:bodyPr wrap="none" lIns="0" tIns="0" rIns="0" bIns="0" anchor="ctr" anchorCtr="1"/>
+            <a:lstStyle/>
+            <a:p>
+              <a:pPr marL="0" marR="0" indent="0" algn="l">
                 <a:lnSpc>
                   <a:spcPts val="1100"/>
                 </a:lnSpc>
@@ -5928,7 +6550,7 @@
         </p:sp>
         <p:sp>
           <p:nvSpPr>
-            <p:cNvPr id="71" name="rc71"/>
+            <p:cNvPr id="78" name="rc78"/>
             <p:cNvSpPr/>
             <p:nvPr/>
           </p:nvSpPr>
@@ -5949,12 +6571,14 @@
           <p:txBody>
             <a:bodyPr/>
             <a:lstStyle/>
-            <a:p/>
-          </p:txBody>
-        </p:sp>
-        <p:sp>
-          <p:nvSpPr>
-            <p:cNvPr id="72" name="tx72"/>
+            <a:p>
+              <a:endParaRPr/>
+            </a:p>
+          </p:txBody>
+        </p:sp>
+        <p:sp>
+          <p:nvSpPr>
+            <p:cNvPr id="79" name="tx79"/>
             <p:cNvSpPr/>
             <p:nvPr/>
           </p:nvSpPr>
@@ -5969,10 +6593,10 @@
             <a:noFill/>
           </p:spPr>
           <p:txBody>
-            <a:bodyPr lIns="0" rIns="0" tIns="0" bIns="0" anchorCtr="1" anchor="ctr" wrap="none"/>
-            <a:lstStyle/>
-            <a:p>
-              <a:pPr algn="l" marL="0" marR="0" indent="0">
+            <a:bodyPr wrap="none" lIns="0" tIns="0" rIns="0" bIns="0" anchor="ctr" anchorCtr="1"/>
+            <a:lstStyle/>
+            <a:p>
+              <a:pPr marL="0" marR="0" indent="0" algn="l">
                 <a:lnSpc>
                   <a:spcPts val="1100"/>
                 </a:lnSpc>
@@ -6000,7 +6624,7 @@
         </p:sp>
         <p:sp>
           <p:nvSpPr>
-            <p:cNvPr id="73" name="rc73"/>
+            <p:cNvPr id="80" name="rc80"/>
             <p:cNvSpPr/>
             <p:nvPr/>
           </p:nvSpPr>
@@ -6021,12 +6645,14 @@
           <p:txBody>
             <a:bodyPr/>
             <a:lstStyle/>
-            <a:p/>
-          </p:txBody>
-        </p:sp>
-        <p:sp>
-          <p:nvSpPr>
-            <p:cNvPr id="74" name="pt74"/>
+            <a:p>
+              <a:endParaRPr/>
+            </a:p>
+          </p:txBody>
+        </p:sp>
+        <p:sp>
+          <p:nvSpPr>
+            <p:cNvPr id="81" name="pt81"/>
             <p:cNvSpPr/>
             <p:nvPr/>
           </p:nvSpPr>
@@ -6056,12 +6682,14 @@
           <p:txBody>
             <a:bodyPr/>
             <a:lstStyle/>
-            <a:p/>
-          </p:txBody>
-        </p:sp>
-        <p:sp>
-          <p:nvSpPr>
-            <p:cNvPr id="75" name="rc75"/>
+            <a:p>
+              <a:endParaRPr/>
+            </a:p>
+          </p:txBody>
+        </p:sp>
+        <p:sp>
+          <p:nvSpPr>
+            <p:cNvPr id="82" name="rc82"/>
             <p:cNvSpPr/>
             <p:nvPr/>
           </p:nvSpPr>
@@ -6082,92 +6710,63 @@
           <p:txBody>
             <a:bodyPr/>
             <a:lstStyle/>
-            <a:p/>
-          </p:txBody>
-        </p:sp>
-        <p:sp>
-          <p:nvSpPr>
-            <p:cNvPr id="76" name="pl76"/>
+            <a:p>
+              <a:endParaRPr/>
+            </a:p>
+          </p:txBody>
+        </p:sp>
+        <p:sp>
+          <p:nvSpPr>
+            <p:cNvPr id="83" name="pg83"/>
             <p:cNvSpPr/>
             <p:nvPr/>
           </p:nvSpPr>
           <p:spPr>
             <a:xfrm>
-              <a:off x="5526814" y="5818518"/>
-              <a:ext cx="127708" cy="0"/>
+              <a:off x="5545517" y="5773367"/>
+              <a:ext cx="90303" cy="90303"/>
             </a:xfrm>
             <a:custGeom>
               <a:avLst/>
+              <a:gdLst/>
+              <a:ahLst/>
+              <a:cxnLst/>
+              <a:rect l="0" t="0" r="0" b="0"/>
               <a:pathLst>
-                <a:path w="127708" h="0">
+                <a:path w="90303" h="90303">
                   <a:moveTo>
+                    <a:pt x="0" y="90303"/>
+                  </a:moveTo>
+                  <a:lnTo>
+                    <a:pt x="90303" y="90303"/>
+                  </a:lnTo>
+                  <a:lnTo>
+                    <a:pt x="90303" y="0"/>
+                  </a:lnTo>
+                  <a:lnTo>
                     <a:pt x="0" y="0"/>
-                  </a:moveTo>
-                  <a:lnTo>
-                    <a:pt x="127708" y="0"/>
-                  </a:lnTo>
+                  </a:lnTo>
+                  <a:close/>
                 </a:path>
               </a:pathLst>
             </a:custGeom>
-            <a:ln w="9000" cap="rnd">
-              <a:solidFill>
-                <a:srgbClr val="007B82">
-                  <a:alpha val="100000"/>
-                </a:srgbClr>
-              </a:solidFill>
-              <a:prstDash val="solid"/>
-              <a:round/>
-            </a:ln>
+            <a:solidFill>
+              <a:srgbClr val="007B82">
+                <a:alpha val="100000"/>
+              </a:srgbClr>
+            </a:solidFill>
           </p:spPr>
           <p:txBody>
             <a:bodyPr/>
             <a:lstStyle/>
-            <a:p/>
-          </p:txBody>
-        </p:sp>
-        <p:sp>
-          <p:nvSpPr>
-            <p:cNvPr id="77" name="pl77"/>
-            <p:cNvSpPr/>
-            <p:nvPr/>
-          </p:nvSpPr>
-          <p:spPr>
-            <a:xfrm>
-              <a:off x="5590668" y="5754664"/>
-              <a:ext cx="0" cy="127708"/>
-            </a:xfrm>
-            <a:custGeom>
-              <a:avLst/>
-              <a:pathLst>
-                <a:path w="0" h="127708">
-                  <a:moveTo>
-                    <a:pt x="0" y="127708"/>
-                  </a:moveTo>
-                  <a:lnTo>
-                    <a:pt x="0" y="0"/>
-                  </a:lnTo>
-                </a:path>
-              </a:pathLst>
-            </a:custGeom>
-            <a:ln w="9000" cap="rnd">
-              <a:solidFill>
-                <a:srgbClr val="007B82">
-                  <a:alpha val="100000"/>
-                </a:srgbClr>
-              </a:solidFill>
-              <a:prstDash val="solid"/>
-              <a:round/>
-            </a:ln>
-          </p:spPr>
-          <p:txBody>
-            <a:bodyPr/>
-            <a:lstStyle/>
-            <a:p/>
-          </p:txBody>
-        </p:sp>
-        <p:sp>
-          <p:nvSpPr>
-            <p:cNvPr id="78" name="rc78"/>
+            <a:p>
+              <a:endParaRPr/>
+            </a:p>
+          </p:txBody>
+        </p:sp>
+        <p:sp>
+          <p:nvSpPr>
+            <p:cNvPr id="84" name="rc84"/>
             <p:cNvSpPr/>
             <p:nvPr/>
           </p:nvSpPr>
@@ -6188,12 +6787,14 @@
           <p:txBody>
             <a:bodyPr/>
             <a:lstStyle/>
-            <a:p/>
-          </p:txBody>
-        </p:sp>
-        <p:sp>
-          <p:nvSpPr>
-            <p:cNvPr id="79" name="pg79"/>
+            <a:p>
+              <a:endParaRPr/>
+            </a:p>
+          </p:txBody>
+        </p:sp>
+        <p:sp>
+          <p:nvSpPr>
+            <p:cNvPr id="85" name="pg85"/>
             <p:cNvSpPr/>
             <p:nvPr/>
           </p:nvSpPr>
@@ -6204,6 +6805,10 @@
             </a:xfrm>
             <a:custGeom>
               <a:avLst/>
+              <a:gdLst/>
+              <a:ahLst/>
+              <a:cxnLst/>
+              <a:rect l="0" t="0" r="0" b="0"/>
               <a:pathLst>
                 <a:path w="121618" h="105324">
                   <a:moveTo>
@@ -6228,12 +6833,14 @@
           <p:txBody>
             <a:bodyPr/>
             <a:lstStyle/>
-            <a:p/>
-          </p:txBody>
-        </p:sp>
-        <p:sp>
-          <p:nvSpPr>
-            <p:cNvPr id="80" name="tx80"/>
+            <a:p>
+              <a:endParaRPr/>
+            </a:p>
+          </p:txBody>
+        </p:sp>
+        <p:sp>
+          <p:nvSpPr>
+            <p:cNvPr id="86" name="tx86"/>
             <p:cNvSpPr/>
             <p:nvPr/>
           </p:nvSpPr>
@@ -6248,10 +6855,10 @@
             <a:noFill/>
           </p:spPr>
           <p:txBody>
-            <a:bodyPr lIns="0" rIns="0" tIns="0" bIns="0" anchorCtr="1" anchor="ctr" wrap="none"/>
-            <a:lstStyle/>
-            <a:p>
-              <a:pPr algn="l" marL="0" marR="0" indent="0">
+            <a:bodyPr wrap="none" lIns="0" tIns="0" rIns="0" bIns="0" anchor="ctr" anchorCtr="1"/>
+            <a:lstStyle/>
+            <a:p>
+              <a:pPr marL="0" marR="0" indent="0" algn="l">
                 <a:lnSpc>
                   <a:spcPts val="880"/>
                 </a:lnSpc>
@@ -6279,7 +6886,7 @@
         </p:sp>
         <p:sp>
           <p:nvSpPr>
-            <p:cNvPr id="81" name="tx81"/>
+            <p:cNvPr id="87" name="tx87"/>
             <p:cNvSpPr/>
             <p:nvPr/>
           </p:nvSpPr>
@@ -6294,10 +6901,10 @@
             <a:noFill/>
           </p:spPr>
           <p:txBody>
-            <a:bodyPr lIns="0" rIns="0" tIns="0" bIns="0" anchorCtr="1" anchor="ctr" wrap="none"/>
-            <a:lstStyle/>
-            <a:p>
-              <a:pPr algn="l" marL="0" marR="0" indent="0">
+            <a:bodyPr wrap="none" lIns="0" tIns="0" rIns="0" bIns="0" anchor="ctr" anchorCtr="1"/>
+            <a:lstStyle/>
+            <a:p>
+              <a:pPr marL="0" marR="0" indent="0" algn="l">
                 <a:lnSpc>
                   <a:spcPts val="880"/>
                 </a:lnSpc>
@@ -6325,7 +6932,7 @@
         </p:sp>
         <p:sp>
           <p:nvSpPr>
-            <p:cNvPr id="82" name="tx82"/>
+            <p:cNvPr id="88" name="tx88"/>
             <p:cNvSpPr/>
             <p:nvPr/>
           </p:nvSpPr>
@@ -6340,10 +6947,10 @@
             <a:noFill/>
           </p:spPr>
           <p:txBody>
-            <a:bodyPr lIns="0" rIns="0" tIns="0" bIns="0" anchorCtr="1" anchor="ctr" wrap="none"/>
-            <a:lstStyle/>
-            <a:p>
-              <a:pPr algn="l" marL="0" marR="0" indent="0">
+            <a:bodyPr wrap="none" lIns="0" tIns="0" rIns="0" bIns="0" anchor="ctr" anchorCtr="1"/>
+            <a:lstStyle/>
+            <a:p>
+              <a:pPr marL="0" marR="0" indent="0" algn="l">
                 <a:lnSpc>
                   <a:spcPts val="880"/>
                 </a:lnSpc>
@@ -6370,6 +6977,41 @@
           </p:txBody>
         </p:sp>
       </p:grpSp>
+      <p:sp>
+        <p:nvSpPr>
+          <p:cNvPr id="89" name="TextBox 88">
+            <a:extLst>
+              <a:ext uri="{FF2B5EF4-FFF2-40B4-BE49-F238E27FC236}">
+                <a16:creationId xmlns:a16="http://schemas.microsoft.com/office/drawing/2014/main" id="{0E4705C3-ADAF-824E-B050-5568DEC46F2F}"/>
+              </a:ext>
+            </a:extLst>
+          </p:cNvPr>
+          <p:cNvSpPr txBox="1"/>
+          <p:nvPr/>
+        </p:nvSpPr>
+        <p:spPr>
+          <a:xfrm>
+            <a:off x="4206081" y="6524625"/>
+            <a:ext cx="4800600" cy="707886"/>
+          </a:xfrm>
+          <a:prstGeom prst="rect">
+            <a:avLst/>
+          </a:prstGeom>
+          <a:noFill/>
+        </p:spPr>
+        <p:txBody>
+          <a:bodyPr wrap="square" rtlCol="0">
+            <a:spAutoFit/>
+          </a:bodyPr>
+          <a:lstStyle/>
+          <a:p>
+            <a:r>
+              <a:rPr lang="en-US" dirty="0"/>
+              <a:t>Make sure to make the ADNI shapes hollow to be consistent with Fig 2</a:t>
+            </a:r>
+          </a:p>
+        </p:txBody>
+      </p:sp>
     </p:spTree>
   </p:cSld>
   <p:clrMapOvr>

</xml_diff>